<commit_message>
[SessionEnd 自動保存] 2026-08-08 16:23
對話結束時 SessionEnd hook 自動保存。詳細工作摘要請查 Obsidian 工作筆記：notebookLM/工作筆記.md
</commit_message>
<xml_diff>
--- a/抽離教學_數學/高一數學/融合班教學資源/第一學段/03_指數與對數/教學簡報/簡報_L2_分數指數冪.pptx
+++ b/抽離教學_數學/高一數學/融合班教學資源/第一學段/03_指數與對數/教學簡報/簡報_L2_分數指數冪.pptx
@@ -2454,7 +2454,7 @@
         </p:nvSpPr>
         <p:spPr>
           <a:xfrm>
-            <a:off x="1412606" y="2597759"/>
+            <a:off x="1412606" y="2631838"/>
             <a:ext cx="175837" cy="218267"/>
           </a:xfrm>
           <a:prstGeom prst="rect">
@@ -2633,7 +2633,7 @@
         </p:nvSpPr>
         <p:spPr>
           <a:xfrm>
-            <a:off x="2327026" y="2597759"/>
+            <a:off x="2327026" y="2631838"/>
             <a:ext cx="175837" cy="218267"/>
           </a:xfrm>
           <a:prstGeom prst="rect">
@@ -2968,7 +2968,7 @@
         </p:nvSpPr>
         <p:spPr>
           <a:xfrm>
-            <a:off x="2069722" y="3397859"/>
+            <a:off x="2069722" y="3431938"/>
             <a:ext cx="175837" cy="218267"/>
           </a:xfrm>
           <a:prstGeom prst="rect">
@@ -3313,7 +3313,7 @@
         </p:nvSpPr>
         <p:spPr>
           <a:xfrm>
-            <a:off x="5189078" y="2597759"/>
+            <a:off x="5189078" y="2631838"/>
             <a:ext cx="175837" cy="218267"/>
           </a:xfrm>
           <a:prstGeom prst="rect">
@@ -3609,7 +3609,7 @@
         </p:nvSpPr>
         <p:spPr>
           <a:xfrm>
-            <a:off x="5301092" y="4197959"/>
+            <a:off x="5301092" y="4232038"/>
             <a:ext cx="175837" cy="218267"/>
           </a:xfrm>
           <a:prstGeom prst="rect">
@@ -3788,7 +3788,7 @@
         </p:nvSpPr>
         <p:spPr>
           <a:xfrm>
-            <a:off x="6215512" y="4197959"/>
+            <a:off x="6215512" y="4232038"/>
             <a:ext cx="175837" cy="218267"/>
           </a:xfrm>
           <a:prstGeom prst="rect">
@@ -3967,7 +3967,7 @@
         </p:nvSpPr>
         <p:spPr>
           <a:xfrm>
-            <a:off x="7129932" y="4197959"/>
+            <a:off x="7129932" y="4232038"/>
             <a:ext cx="175837" cy="218267"/>
           </a:xfrm>
           <a:prstGeom prst="rect">
@@ -4312,7 +4312,7 @@
         </p:nvSpPr>
         <p:spPr>
           <a:xfrm>
-            <a:off x="9232250" y="2997809"/>
+            <a:off x="9232250" y="3031888"/>
             <a:ext cx="175837" cy="218267"/>
           </a:xfrm>
           <a:prstGeom prst="rect">
@@ -4491,7 +4491,7 @@
         </p:nvSpPr>
         <p:spPr>
           <a:xfrm>
-            <a:off x="9922977" y="2997809"/>
+            <a:off x="9922977" y="3031888"/>
             <a:ext cx="175837" cy="218267"/>
           </a:xfrm>
           <a:prstGeom prst="rect">
@@ -4631,7 +4631,7 @@
         </p:nvSpPr>
         <p:spPr>
           <a:xfrm>
-            <a:off x="9409938" y="3498296"/>
+            <a:off x="9409938" y="3525241"/>
             <a:ext cx="227564" cy="352044"/>
           </a:xfrm>
           <a:prstGeom prst="rect">
@@ -4849,7 +4849,7 @@
         </p:nvSpPr>
         <p:spPr>
           <a:xfrm>
-            <a:off x="10530759" y="3397859"/>
+            <a:off x="10530759" y="3431938"/>
             <a:ext cx="175837" cy="218267"/>
           </a:xfrm>
           <a:prstGeom prst="rect">
@@ -5028,7 +5028,7 @@
         </p:nvSpPr>
         <p:spPr>
           <a:xfrm>
-            <a:off x="11225233" y="3397859"/>
+            <a:off x="11225233" y="3431938"/>
             <a:ext cx="175837" cy="218267"/>
           </a:xfrm>
           <a:prstGeom prst="rect">
@@ -5872,7 +5872,7 @@
         </p:nvSpPr>
         <p:spPr>
           <a:xfrm>
-            <a:off x="2899546" y="4182407"/>
+            <a:off x="2899546" y="4214823"/>
             <a:ext cx="187893" cy="249448"/>
           </a:xfrm>
           <a:prstGeom prst="rect">
@@ -5951,7 +5951,7 @@
         <p:spPr>
           <a:xfrm>
             <a:off x="1005840" y="4581144"/>
-            <a:ext cx="3938016" cy="457200"/>
+            <a:ext cx="3425952" cy="457200"/>
           </a:xfrm>
           <a:prstGeom prst="rect">
             <a:avLst/>
@@ -5975,7 +5975,7 @@
                 <a:ea typeface="Microsoft JhengHei" pitchFamily="34" charset="-122"/>
                 <a:cs typeface="Microsoft JhengHei" pitchFamily="34" charset="-120"/>
               </a:rPr>
-              <a:t>② 喺分母 → 指數加負號：1 / </a:t>
+              <a:t>② 喺分母 → 指數加負號：</a:t>
             </a:r>
             <a:endParaRPr lang="en-US" sz="2400" dirty="0"/>
           </a:p>
@@ -5983,13 +5983,192 @@
       </p:sp>
       <p:sp>
         <p:nvSpPr>
-          <p:cNvPr id="24" name="Text 22"/>
-          <p:cNvSpPr/>
-          <p:nvPr/>
-        </p:nvSpPr>
-        <p:spPr>
-          <a:xfrm>
-            <a:off x="4943856" y="4581144"/>
+          <p:cNvPr id="24" name="Shape 22"/>
+          <p:cNvSpPr/>
+          <p:nvPr/>
+        </p:nvSpPr>
+        <p:spPr>
+          <a:xfrm>
+            <a:off x="4477512" y="4809744"/>
+            <a:ext cx="467220" cy="0"/>
+          </a:xfrm>
+          <a:prstGeom prst="line">
+            <a:avLst/>
+          </a:prstGeom>
+          <a:noFill/>
+          <a:ln w="28575">
+            <a:solidFill>
+              <a:srgbClr val="202A26"/>
+            </a:solidFill>
+            <a:prstDash val="solid"/>
+          </a:ln>
+        </p:spPr>
+      </p:sp>
+      <p:sp>
+        <p:nvSpPr>
+          <p:cNvPr id="25" name="Text 23"/>
+          <p:cNvSpPr/>
+          <p:nvPr/>
+        </p:nvSpPr>
+        <p:spPr>
+          <a:xfrm>
+            <a:off x="4587617" y="4426184"/>
+            <a:ext cx="247010" cy="402336"/>
+          </a:xfrm>
+          <a:prstGeom prst="rect">
+            <a:avLst/>
+          </a:prstGeom>
+          <a:noFill/>
+          <a:ln/>
+        </p:spPr>
+        <p:txBody>
+          <a:bodyPr wrap="none" lIns="0" tIns="0" rIns="0" bIns="0" rtlCol="0" anchor="ctr"/>
+          <a:lstStyle/>
+          <a:p>
+            <a:pPr algn="ctr" indent="0" marL="0">
+              <a:buNone/>
+            </a:pPr>
+            <a:r>
+              <a:rPr lang="en-US" sz="2112" b="1" dirty="0">
+                <a:solidFill>
+                  <a:srgbClr val="202A26"/>
+                </a:solidFill>
+                <a:latin typeface="Microsoft JhengHei" pitchFamily="34" charset="0"/>
+                <a:ea typeface="Microsoft JhengHei" pitchFamily="34" charset="-122"/>
+                <a:cs typeface="Microsoft JhengHei" pitchFamily="34" charset="-120"/>
+              </a:rPr>
+              <a:t>1</a:t>
+            </a:r>
+            <a:endParaRPr lang="en-US" sz="2112" dirty="0"/>
+          </a:p>
+        </p:txBody>
+      </p:sp>
+      <p:sp>
+        <p:nvSpPr>
+          <p:cNvPr id="26" name="Text 24"/>
+          <p:cNvSpPr/>
+          <p:nvPr/>
+        </p:nvSpPr>
+        <p:spPr>
+          <a:xfrm>
+            <a:off x="4504944" y="4861365"/>
+            <a:ext cx="247010" cy="402336"/>
+          </a:xfrm>
+          <a:prstGeom prst="rect">
+            <a:avLst/>
+          </a:prstGeom>
+          <a:noFill/>
+          <a:ln/>
+        </p:spPr>
+        <p:txBody>
+          <a:bodyPr wrap="none" lIns="0" tIns="0" rIns="0" bIns="0" rtlCol="0" anchor="ctr"/>
+          <a:lstStyle/>
+          <a:p>
+            <a:pPr algn="ctr" indent="0" marL="0">
+              <a:buNone/>
+            </a:pPr>
+            <a:r>
+              <a:rPr lang="en-US" sz="2112" b="1" dirty="0">
+                <a:solidFill>
+                  <a:srgbClr val="202A26"/>
+                </a:solidFill>
+                <a:latin typeface="Microsoft JhengHei" pitchFamily="34" charset="0"/>
+                <a:ea typeface="Microsoft JhengHei" pitchFamily="34" charset="-122"/>
+                <a:cs typeface="Microsoft JhengHei" pitchFamily="34" charset="-120"/>
+              </a:rPr>
+              <a:t>a</a:t>
+            </a:r>
+            <a:endParaRPr lang="en-US" sz="2112" dirty="0"/>
+          </a:p>
+        </p:txBody>
+      </p:sp>
+      <p:sp>
+        <p:nvSpPr>
+          <p:cNvPr id="27" name="Text 25"/>
+          <p:cNvSpPr/>
+          <p:nvPr/>
+        </p:nvSpPr>
+        <p:spPr>
+          <a:xfrm>
+            <a:off x="4725649" y="4830519"/>
+            <a:ext cx="187893" cy="249448"/>
+          </a:xfrm>
+          <a:prstGeom prst="rect">
+            <a:avLst/>
+          </a:prstGeom>
+          <a:noFill/>
+          <a:ln/>
+        </p:spPr>
+        <p:txBody>
+          <a:bodyPr wrap="none" lIns="0" tIns="0" rIns="0" bIns="0" rtlCol="0" anchor="ctr"/>
+          <a:lstStyle/>
+          <a:p>
+            <a:pPr algn="ctr" indent="0" marL="0">
+              <a:buNone/>
+            </a:pPr>
+            <a:r>
+              <a:rPr lang="en-US" sz="1309" b="1" dirty="0">
+                <a:solidFill>
+                  <a:srgbClr val="202A26"/>
+                </a:solidFill>
+                <a:latin typeface="Microsoft JhengHei" pitchFamily="34" charset="0"/>
+                <a:ea typeface="Microsoft JhengHei" pitchFamily="34" charset="-122"/>
+                <a:cs typeface="Microsoft JhengHei" pitchFamily="34" charset="-120"/>
+              </a:rPr>
+              <a:t>n</a:t>
+            </a:r>
+            <a:endParaRPr lang="en-US" sz="1309" dirty="0"/>
+          </a:p>
+        </p:txBody>
+      </p:sp>
+      <p:sp>
+        <p:nvSpPr>
+          <p:cNvPr id="28" name="Text 26"/>
+          <p:cNvSpPr/>
+          <p:nvPr/>
+        </p:nvSpPr>
+        <p:spPr>
+          <a:xfrm>
+            <a:off x="4990452" y="4581144"/>
+            <a:ext cx="426720" cy="457200"/>
+          </a:xfrm>
+          <a:prstGeom prst="rect">
+            <a:avLst/>
+          </a:prstGeom>
+          <a:noFill/>
+          <a:ln/>
+        </p:spPr>
+        <p:txBody>
+          <a:bodyPr wrap="none" lIns="0" tIns="0" rIns="0" bIns="0" rtlCol="0" anchor="ctr"/>
+          <a:lstStyle/>
+          <a:p>
+            <a:pPr algn="ctr" indent="0" marL="0">
+              <a:buNone/>
+            </a:pPr>
+            <a:r>
+              <a:rPr lang="en-US" sz="2400" b="1" dirty="0">
+                <a:solidFill>
+                  <a:srgbClr val="202A26"/>
+                </a:solidFill>
+                <a:latin typeface="Microsoft JhengHei" pitchFamily="34" charset="0"/>
+                <a:ea typeface="Microsoft JhengHei" pitchFamily="34" charset="-122"/>
+                <a:cs typeface="Microsoft JhengHei" pitchFamily="34" charset="-120"/>
+              </a:rPr>
+              <a:t> = </a:t>
+            </a:r>
+            <a:endParaRPr lang="en-US" sz="2400" dirty="0"/>
+          </a:p>
+        </p:txBody>
+      </p:sp>
+      <p:sp>
+        <p:nvSpPr>
+          <p:cNvPr id="29" name="Text 27"/>
+          <p:cNvSpPr/>
+          <p:nvPr/>
+        </p:nvSpPr>
+        <p:spPr>
+          <a:xfrm>
+            <a:off x="5417172" y="4581144"/>
             <a:ext cx="268224" cy="457200"/>
           </a:xfrm>
           <a:prstGeom prst="rect">
@@ -6022,14 +6201,14 @@
       </p:sp>
       <p:sp>
         <p:nvSpPr>
-          <p:cNvPr id="25" name="Text 23"/>
-          <p:cNvSpPr/>
-          <p:nvPr/>
-        </p:nvSpPr>
-        <p:spPr>
-          <a:xfrm>
-            <a:off x="5183934" y="4546092"/>
-            <a:ext cx="201046" cy="283464"/>
+          <p:cNvPr id="30" name="Text 28"/>
+          <p:cNvSpPr/>
+          <p:nvPr/>
+        </p:nvSpPr>
+        <p:spPr>
+          <a:xfrm>
+            <a:off x="5641905" y="4546092"/>
+            <a:ext cx="310652" cy="283464"/>
           </a:xfrm>
           <a:prstGeom prst="rect">
             <a:avLst/>
@@ -6053,7 +6232,7 @@
                 <a:ea typeface="Microsoft JhengHei" pitchFamily="34" charset="-122"/>
                 <a:cs typeface="Microsoft JhengHei" pitchFamily="34" charset="-120"/>
               </a:rPr>
-              <a:t>n</a:t>
+              <a:t>-n</a:t>
             </a:r>
             <a:endParaRPr lang="en-US" sz="1488" dirty="0"/>
           </a:p>
@@ -6061,124 +6240,7 @@
       </p:sp>
       <p:sp>
         <p:nvSpPr>
-          <p:cNvPr id="26" name="Text 24"/>
-          <p:cNvSpPr/>
-          <p:nvPr/>
-        </p:nvSpPr>
-        <p:spPr>
-          <a:xfrm>
-            <a:off x="5389001" y="4581144"/>
-            <a:ext cx="426720" cy="457200"/>
-          </a:xfrm>
-          <a:prstGeom prst="rect">
-            <a:avLst/>
-          </a:prstGeom>
-          <a:noFill/>
-          <a:ln/>
-        </p:spPr>
-        <p:txBody>
-          <a:bodyPr wrap="none" lIns="0" tIns="0" rIns="0" bIns="0" rtlCol="0" anchor="ctr"/>
-          <a:lstStyle/>
-          <a:p>
-            <a:pPr algn="ctr" indent="0" marL="0">
-              <a:buNone/>
-            </a:pPr>
-            <a:r>
-              <a:rPr lang="en-US" sz="2400" b="1" dirty="0">
-                <a:solidFill>
-                  <a:srgbClr val="202A26"/>
-                </a:solidFill>
-                <a:latin typeface="Microsoft JhengHei" pitchFamily="34" charset="0"/>
-                <a:ea typeface="Microsoft JhengHei" pitchFamily="34" charset="-122"/>
-                <a:cs typeface="Microsoft JhengHei" pitchFamily="34" charset="-120"/>
-              </a:rPr>
-              <a:t> = </a:t>
-            </a:r>
-            <a:endParaRPr lang="en-US" sz="2400" dirty="0"/>
-          </a:p>
-        </p:txBody>
-      </p:sp>
-      <p:sp>
-        <p:nvSpPr>
-          <p:cNvPr id="27" name="Text 25"/>
-          <p:cNvSpPr/>
-          <p:nvPr/>
-        </p:nvSpPr>
-        <p:spPr>
-          <a:xfrm>
-            <a:off x="5815721" y="4581144"/>
-            <a:ext cx="268224" cy="457200"/>
-          </a:xfrm>
-          <a:prstGeom prst="rect">
-            <a:avLst/>
-          </a:prstGeom>
-          <a:noFill/>
-          <a:ln/>
-        </p:spPr>
-        <p:txBody>
-          <a:bodyPr wrap="none" lIns="0" tIns="0" rIns="0" bIns="0" rtlCol="0" anchor="ctr"/>
-          <a:lstStyle/>
-          <a:p>
-            <a:pPr algn="ctr" indent="0" marL="0">
-              <a:buNone/>
-            </a:pPr>
-            <a:r>
-              <a:rPr lang="en-US" sz="2400" b="1" dirty="0">
-                <a:solidFill>
-                  <a:srgbClr val="202A26"/>
-                </a:solidFill>
-                <a:latin typeface="Microsoft JhengHei" pitchFamily="34" charset="0"/>
-                <a:ea typeface="Microsoft JhengHei" pitchFamily="34" charset="-122"/>
-                <a:cs typeface="Microsoft JhengHei" pitchFamily="34" charset="-120"/>
-              </a:rPr>
-              <a:t>a</a:t>
-            </a:r>
-            <a:endParaRPr lang="en-US" sz="2400" dirty="0"/>
-          </a:p>
-        </p:txBody>
-      </p:sp>
-      <p:sp>
-        <p:nvSpPr>
-          <p:cNvPr id="28" name="Text 26"/>
-          <p:cNvSpPr/>
-          <p:nvPr/>
-        </p:nvSpPr>
-        <p:spPr>
-          <a:xfrm>
-            <a:off x="6040453" y="4546092"/>
-            <a:ext cx="310652" cy="283464"/>
-          </a:xfrm>
-          <a:prstGeom prst="rect">
-            <a:avLst/>
-          </a:prstGeom>
-          <a:noFill/>
-          <a:ln/>
-        </p:spPr>
-        <p:txBody>
-          <a:bodyPr wrap="none" lIns="0" tIns="0" rIns="0" bIns="0" rtlCol="0" anchor="ctr"/>
-          <a:lstStyle/>
-          <a:p>
-            <a:pPr algn="ctr" indent="0" marL="0">
-              <a:buNone/>
-            </a:pPr>
-            <a:r>
-              <a:rPr lang="en-US" sz="1488" b="1" dirty="0">
-                <a:solidFill>
-                  <a:srgbClr val="202A26"/>
-                </a:solidFill>
-                <a:latin typeface="Microsoft JhengHei" pitchFamily="34" charset="0"/>
-                <a:ea typeface="Microsoft JhengHei" pitchFamily="34" charset="-122"/>
-                <a:cs typeface="Microsoft JhengHei" pitchFamily="34" charset="-120"/>
-              </a:rPr>
-              <a:t>-n</a:t>
-            </a:r>
-            <a:endParaRPr lang="en-US" sz="1488" dirty="0"/>
-          </a:p>
-        </p:txBody>
-      </p:sp>
-      <p:sp>
-        <p:nvSpPr>
-          <p:cNvPr id="29" name="Text 27"/>
+          <p:cNvPr id="31" name="Text 29"/>
           <p:cNvSpPr/>
           <p:nvPr/>
         </p:nvSpPr>
@@ -7092,7 +7154,7 @@
         </p:nvSpPr>
         <p:spPr>
           <a:xfrm>
-            <a:off x="4341845" y="2706644"/>
+            <a:off x="4341845" y="2739615"/>
             <a:ext cx="183874" cy="239055"/>
           </a:xfrm>
           <a:prstGeom prst="rect">
@@ -8668,7 +8730,7 @@
         </p:nvSpPr>
         <p:spPr>
           <a:xfrm>
-            <a:off x="4792698" y="2463906"/>
+            <a:off x="4792698" y="2487452"/>
             <a:ext cx="252196" cy="415747"/>
           </a:xfrm>
           <a:prstGeom prst="rect">
@@ -9388,7 +9450,7 @@
         </p:nvSpPr>
         <p:spPr>
           <a:xfrm>
-            <a:off x="8984491" y="5204099"/>
+            <a:off x="8984491" y="5237070"/>
             <a:ext cx="183874" cy="239055"/>
           </a:xfrm>
           <a:prstGeom prst="rect">
@@ -10061,7 +10123,7 @@
         </p:nvSpPr>
         <p:spPr>
           <a:xfrm>
-            <a:off x="5268525" y="2536187"/>
+            <a:off x="5268525" y="2569712"/>
             <a:ext cx="179856" cy="228661"/>
           </a:xfrm>
           <a:prstGeom prst="rect">
@@ -10462,7 +10524,7 @@
         </p:nvSpPr>
         <p:spPr>
           <a:xfrm>
-            <a:off x="5268525" y="3321047"/>
+            <a:off x="5268525" y="3354572"/>
             <a:ext cx="179856" cy="228661"/>
           </a:xfrm>
           <a:prstGeom prst="rect">
@@ -10902,7 +10964,7 @@
         </p:nvSpPr>
         <p:spPr>
           <a:xfrm>
-            <a:off x="5268525" y="4105907"/>
+            <a:off x="5268525" y="4139432"/>
             <a:ext cx="179856" cy="228661"/>
           </a:xfrm>
           <a:prstGeom prst="rect">
@@ -11303,7 +11365,7 @@
         </p:nvSpPr>
         <p:spPr>
           <a:xfrm>
-            <a:off x="5268525" y="4890767"/>
+            <a:off x="5268525" y="4924292"/>
             <a:ext cx="179856" cy="228661"/>
           </a:xfrm>
           <a:prstGeom prst="rect">
@@ -11425,98 +11487,20 @@
       </p:sp>
       <p:sp>
         <p:nvSpPr>
-          <p:cNvPr id="65" name="Text 63"/>
-          <p:cNvSpPr/>
-          <p:nvPr/>
-        </p:nvSpPr>
-        <p:spPr>
-          <a:xfrm>
-            <a:off x="1430783" y="5588508"/>
-            <a:ext cx="560832" cy="419100"/>
-          </a:xfrm>
-          <a:prstGeom prst="rect">
-            <a:avLst/>
-          </a:prstGeom>
-          <a:noFill/>
-          <a:ln/>
-        </p:spPr>
-        <p:txBody>
-          <a:bodyPr wrap="none" lIns="0" tIns="0" rIns="0" bIns="0" rtlCol="0" anchor="ctr"/>
-          <a:lstStyle/>
-          <a:p>
-            <a:pPr algn="ctr" indent="0" marL="0">
-              <a:buNone/>
-            </a:pPr>
-            <a:r>
-              <a:rPr lang="en-US" sz="2200" b="1" dirty="0">
-                <a:solidFill>
-                  <a:srgbClr val="202A26"/>
-                </a:solidFill>
-                <a:latin typeface="Microsoft JhengHei" pitchFamily="34" charset="0"/>
-                <a:ea typeface="Microsoft JhengHei" pitchFamily="34" charset="-122"/>
-                <a:cs typeface="Microsoft JhengHei" pitchFamily="34" charset="-120"/>
-              </a:rPr>
-              <a:t>1 / </a:t>
-            </a:r>
-            <a:endParaRPr lang="en-US" sz="2200" dirty="0"/>
-          </a:p>
-        </p:txBody>
-      </p:sp>
-      <p:sp>
-        <p:nvSpPr>
-          <p:cNvPr id="66" name="Text 64"/>
-          <p:cNvSpPr/>
-          <p:nvPr/>
-        </p:nvSpPr>
-        <p:spPr>
-          <a:xfrm>
-            <a:off x="1991615" y="5532628"/>
-            <a:ext cx="188671" cy="217932"/>
-          </a:xfrm>
-          <a:prstGeom prst="rect">
-            <a:avLst/>
-          </a:prstGeom>
-          <a:noFill/>
-          <a:ln/>
-        </p:spPr>
-        <p:txBody>
-          <a:bodyPr wrap="none" lIns="0" tIns="0" rIns="0" bIns="0" rtlCol="0" anchor="ctr"/>
-          <a:lstStyle/>
-          <a:p>
-            <a:pPr algn="ctr" indent="0" marL="0">
-              <a:buNone/>
-            </a:pPr>
-            <a:r>
-              <a:rPr lang="en-US" sz="1320" b="1" dirty="0">
-                <a:solidFill>
-                  <a:srgbClr val="202A26"/>
-                </a:solidFill>
-                <a:latin typeface="Microsoft JhengHei" pitchFamily="34" charset="0"/>
-                <a:ea typeface="Microsoft JhengHei" pitchFamily="34" charset="-122"/>
-                <a:cs typeface="Microsoft JhengHei" pitchFamily="34" charset="-120"/>
-              </a:rPr>
-              <a:t>3</a:t>
-            </a:r>
-            <a:endParaRPr lang="en-US" sz="1320" dirty="0"/>
-          </a:p>
-        </p:txBody>
-      </p:sp>
-      <p:sp>
-        <p:nvSpPr>
-          <p:cNvPr id="67" name="Shape 65"/>
-          <p:cNvSpPr/>
-          <p:nvPr/>
-        </p:nvSpPr>
-        <p:spPr>
-          <a:xfrm>
-            <a:off x="2170853" y="5792470"/>
-            <a:ext cx="48839" cy="83820"/>
+          <p:cNvPr id="65" name="Shape 63"/>
+          <p:cNvSpPr/>
+          <p:nvPr/>
+        </p:nvSpPr>
+        <p:spPr>
+          <a:xfrm>
+            <a:off x="1710882" y="5798058"/>
+            <a:ext cx="784476" cy="0"/>
           </a:xfrm>
           <a:prstGeom prst="line">
             <a:avLst/>
           </a:prstGeom>
           <a:noFill/>
-          <a:ln w="13194">
+          <a:ln w="28575">
             <a:solidFill>
               <a:srgbClr val="202A26"/>
             </a:solidFill>
@@ -11526,20 +11510,98 @@
       </p:sp>
       <p:sp>
         <p:nvSpPr>
+          <p:cNvPr id="66" name="Text 64"/>
+          <p:cNvSpPr/>
+          <p:nvPr/>
+        </p:nvSpPr>
+        <p:spPr>
+          <a:xfrm>
+            <a:off x="1986097" y="5446461"/>
+            <a:ext cx="234046" cy="368808"/>
+          </a:xfrm>
+          <a:prstGeom prst="rect">
+            <a:avLst/>
+          </a:prstGeom>
+          <a:noFill/>
+          <a:ln/>
+        </p:spPr>
+        <p:txBody>
+          <a:bodyPr wrap="none" lIns="0" tIns="0" rIns="0" bIns="0" rtlCol="0" anchor="ctr"/>
+          <a:lstStyle/>
+          <a:p>
+            <a:pPr algn="ctr" indent="0" marL="0">
+              <a:buNone/>
+            </a:pPr>
+            <a:r>
+              <a:rPr lang="en-US" sz="1936" b="1" dirty="0">
+                <a:solidFill>
+                  <a:srgbClr val="202A26"/>
+                </a:solidFill>
+                <a:latin typeface="Microsoft JhengHei" pitchFamily="34" charset="0"/>
+                <a:ea typeface="Microsoft JhengHei" pitchFamily="34" charset="-122"/>
+                <a:cs typeface="Microsoft JhengHei" pitchFamily="34" charset="-120"/>
+              </a:rPr>
+              <a:t>1</a:t>
+            </a:r>
+            <a:endParaRPr lang="en-US" sz="1936" dirty="0"/>
+          </a:p>
+        </p:txBody>
+      </p:sp>
+      <p:sp>
+        <p:nvSpPr>
+          <p:cNvPr id="67" name="Text 65"/>
+          <p:cNvSpPr/>
+          <p:nvPr/>
+        </p:nvSpPr>
+        <p:spPr>
+          <a:xfrm>
+            <a:off x="1738314" y="5843778"/>
+            <a:ext cx="177003" cy="191780"/>
+          </a:xfrm>
+          <a:prstGeom prst="rect">
+            <a:avLst/>
+          </a:prstGeom>
+          <a:noFill/>
+          <a:ln/>
+        </p:spPr>
+        <p:txBody>
+          <a:bodyPr wrap="none" lIns="0" tIns="0" rIns="0" bIns="0" rtlCol="0" anchor="ctr"/>
+          <a:lstStyle/>
+          <a:p>
+            <a:pPr algn="ctr" indent="0" marL="0">
+              <a:buNone/>
+            </a:pPr>
+            <a:r>
+              <a:rPr lang="en-US" sz="1162" b="1" dirty="0">
+                <a:solidFill>
+                  <a:srgbClr val="202A26"/>
+                </a:solidFill>
+                <a:latin typeface="Microsoft JhengHei" pitchFamily="34" charset="0"/>
+                <a:ea typeface="Microsoft JhengHei" pitchFamily="34" charset="-122"/>
+                <a:cs typeface="Microsoft JhengHei" pitchFamily="34" charset="-120"/>
+              </a:rPr>
+              <a:t>3</a:t>
+            </a:r>
+            <a:endParaRPr lang="en-US" sz="1162" dirty="0"/>
+          </a:p>
+        </p:txBody>
+      </p:sp>
+      <p:sp>
+        <p:nvSpPr>
           <p:cNvPr id="68" name="Shape 66"/>
           <p:cNvSpPr/>
           <p:nvPr/>
         </p:nvSpPr>
         <p:spPr>
-          <a:xfrm flipV="1">
-            <a:off x="2219692" y="5582361"/>
-            <a:ext cx="79685" cy="293929"/>
+          <a:xfrm>
+            <a:off x="1906467" y="6072439"/>
+            <a:ext cx="42978" cy="73762"/>
           </a:xfrm>
           <a:prstGeom prst="line">
             <a:avLst/>
           </a:prstGeom>
           <a:noFill/>
-          <a:ln w="13194">
+          <a:ln w="12700">
             <a:solidFill>
               <a:srgbClr val="202A26"/>
             </a:solidFill>
@@ -11554,15 +11616,15 @@
           <p:nvPr/>
         </p:nvSpPr>
         <p:spPr>
-          <a:xfrm>
-            <a:off x="2299377" y="5582361"/>
-            <a:ext cx="458951" cy="0"/>
+          <a:xfrm flipV="1">
+            <a:off x="1949446" y="5887543"/>
+            <a:ext cx="70123" cy="258657"/>
           </a:xfrm>
           <a:prstGeom prst="line">
             <a:avLst/>
           </a:prstGeom>
           <a:noFill/>
-          <a:ln w="14513">
+          <a:ln w="12700">
             <a:solidFill>
               <a:srgbClr val="202A26"/>
             </a:solidFill>
@@ -11572,30 +11634,53 @@
       </p:sp>
       <p:sp>
         <p:nvSpPr>
-          <p:cNvPr id="70" name="Text 68"/>
-          <p:cNvSpPr/>
-          <p:nvPr/>
-        </p:nvSpPr>
-        <p:spPr>
-          <a:xfrm>
-            <a:off x="2317665" y="5588508"/>
-            <a:ext cx="253492" cy="419100"/>
-          </a:xfrm>
-          <a:prstGeom prst="rect">
-            <a:avLst/>
-          </a:prstGeom>
-          <a:noFill/>
-          <a:ln/>
-        </p:spPr>
-        <p:txBody>
-          <a:bodyPr wrap="none" lIns="0" tIns="0" rIns="0" bIns="0" rtlCol="0" anchor="ctr"/>
-          <a:lstStyle/>
-          <a:p>
-            <a:pPr algn="ctr" indent="0" marL="0">
-              <a:buNone/>
-            </a:pPr>
-            <a:r>
-              <a:rPr lang="en-US" sz="2200" b="1" dirty="0">
+          <p:cNvPr id="70" name="Shape 68"/>
+          <p:cNvSpPr/>
+          <p:nvPr/>
+        </p:nvSpPr>
+        <p:spPr>
+          <a:xfrm>
+            <a:off x="2019568" y="5887543"/>
+            <a:ext cx="428895" cy="0"/>
+          </a:xfrm>
+          <a:prstGeom prst="line">
+            <a:avLst/>
+          </a:prstGeom>
+          <a:noFill/>
+          <a:ln w="13970">
+            <a:solidFill>
+              <a:srgbClr val="202A26"/>
+            </a:solidFill>
+            <a:prstDash val="solid"/>
+          </a:ln>
+        </p:spPr>
+      </p:sp>
+      <p:sp>
+        <p:nvSpPr>
+          <p:cNvPr id="71" name="Text 69"/>
+          <p:cNvSpPr/>
+          <p:nvPr/>
+        </p:nvSpPr>
+        <p:spPr>
+          <a:xfrm>
+            <a:off x="2037856" y="5892952"/>
+            <a:ext cx="234046" cy="368808"/>
+          </a:xfrm>
+          <a:prstGeom prst="rect">
+            <a:avLst/>
+          </a:prstGeom>
+          <a:noFill/>
+          <a:ln/>
+        </p:spPr>
+        <p:txBody>
+          <a:bodyPr wrap="none" lIns="0" tIns="0" rIns="0" bIns="0" rtlCol="0" anchor="ctr"/>
+          <a:lstStyle/>
+          <a:p>
+            <a:pPr algn="ctr" indent="0" marL="0">
+              <a:buNone/>
+            </a:pPr>
+            <a:r>
+              <a:rPr lang="en-US" sz="1936" b="1" dirty="0">
                 <a:solidFill>
                   <a:srgbClr val="202A26"/>
                 </a:solidFill>
@@ -11605,36 +11690,36 @@
               </a:rPr>
               <a:t>a</a:t>
             </a:r>
-            <a:endParaRPr lang="en-US" sz="2200" dirty="0"/>
-          </a:p>
-        </p:txBody>
-      </p:sp>
-      <p:sp>
-        <p:nvSpPr>
-          <p:cNvPr id="71" name="Text 69"/>
-          <p:cNvSpPr/>
-          <p:nvPr/>
-        </p:nvSpPr>
-        <p:spPr>
-          <a:xfrm>
-            <a:off x="2544289" y="5556377"/>
-            <a:ext cx="191912" cy="259842"/>
-          </a:xfrm>
-          <a:prstGeom prst="rect">
-            <a:avLst/>
-          </a:prstGeom>
-          <a:noFill/>
-          <a:ln/>
-        </p:spPr>
-        <p:txBody>
-          <a:bodyPr wrap="none" lIns="0" tIns="0" rIns="0" bIns="0" rtlCol="0" anchor="ctr"/>
-          <a:lstStyle/>
-          <a:p>
-            <a:pPr algn="ctr" indent="0" marL="0">
-              <a:buNone/>
-            </a:pPr>
-            <a:r>
-              <a:rPr lang="en-US" sz="1364" b="1" dirty="0">
+            <a:endParaRPr lang="en-US" sz="1936" dirty="0"/>
+          </a:p>
+        </p:txBody>
+      </p:sp>
+      <p:sp>
+        <p:nvSpPr>
+          <p:cNvPr id="72" name="Text 70"/>
+          <p:cNvSpPr/>
+          <p:nvPr/>
+        </p:nvSpPr>
+        <p:spPr>
+          <a:xfrm>
+            <a:off x="2246722" y="5864677"/>
+            <a:ext cx="179856" cy="228661"/>
+          </a:xfrm>
+          <a:prstGeom prst="rect">
+            <a:avLst/>
+          </a:prstGeom>
+          <a:noFill/>
+          <a:ln/>
+        </p:spPr>
+        <p:txBody>
+          <a:bodyPr wrap="none" lIns="0" tIns="0" rIns="0" bIns="0" rtlCol="0" anchor="ctr"/>
+          <a:lstStyle/>
+          <a:p>
+            <a:pPr algn="ctr" indent="0" marL="0">
+              <a:buNone/>
+            </a:pPr>
+            <a:r>
+              <a:rPr lang="en-US" sz="1200" b="1" dirty="0">
                 <a:solidFill>
                   <a:srgbClr val="202A26"/>
                 </a:solidFill>
@@ -11644,13 +11729,13 @@
               </a:rPr>
               <a:t>5</a:t>
             </a:r>
-            <a:endParaRPr lang="en-US" sz="1364" dirty="0"/>
-          </a:p>
-        </p:txBody>
-      </p:sp>
-      <p:sp>
-        <p:nvSpPr>
-          <p:cNvPr id="72" name="Shape 70"/>
+            <a:endParaRPr lang="en-US" sz="1200" dirty="0"/>
+          </a:p>
+        </p:txBody>
+      </p:sp>
+      <p:sp>
+        <p:nvSpPr>
+          <p:cNvPr id="73" name="Shape 71"/>
           <p:cNvSpPr/>
           <p:nvPr/>
         </p:nvSpPr>
@@ -11675,7 +11760,7 @@
       </p:sp>
       <p:sp>
         <p:nvSpPr>
-          <p:cNvPr id="73" name="Text 71"/>
+          <p:cNvPr id="74" name="Text 72"/>
           <p:cNvSpPr/>
           <p:nvPr/>
         </p:nvSpPr>
@@ -11714,7 +11799,7 @@
       </p:sp>
       <p:sp>
         <p:nvSpPr>
-          <p:cNvPr id="74" name="Text 72"/>
+          <p:cNvPr id="75" name="Text 73"/>
           <p:cNvSpPr/>
           <p:nvPr/>
         </p:nvSpPr>
@@ -11753,7 +11838,7 @@
       </p:sp>
       <p:sp>
         <p:nvSpPr>
-          <p:cNvPr id="75" name="Shape 73"/>
+          <p:cNvPr id="76" name="Shape 74"/>
           <p:cNvSpPr/>
           <p:nvPr/>
         </p:nvSpPr>
@@ -11776,7 +11861,7 @@
       </p:sp>
       <p:sp>
         <p:nvSpPr>
-          <p:cNvPr id="76" name="Text 74"/>
+          <p:cNvPr id="77" name="Text 75"/>
           <p:cNvSpPr/>
           <p:nvPr/>
         </p:nvSpPr>
@@ -11815,13 +11900,13 @@
       </p:sp>
       <p:sp>
         <p:nvSpPr>
-          <p:cNvPr id="77" name="Text 75"/>
-          <p:cNvSpPr/>
-          <p:nvPr/>
-        </p:nvSpPr>
-        <p:spPr>
-          <a:xfrm>
-            <a:off x="5349129" y="5675627"/>
+          <p:cNvPr id="78" name="Text 76"/>
+          <p:cNvSpPr/>
+          <p:nvPr/>
+        </p:nvSpPr>
+        <p:spPr>
+          <a:xfrm>
+            <a:off x="5349129" y="5709152"/>
             <a:ext cx="179856" cy="228661"/>
           </a:xfrm>
           <a:prstGeom prst="rect">
@@ -11854,7 +11939,7 @@
       </p:sp>
       <p:sp>
         <p:nvSpPr>
-          <p:cNvPr id="78" name="Shape 76"/>
+          <p:cNvPr id="79" name="Shape 77"/>
           <p:cNvSpPr/>
           <p:nvPr/>
         </p:nvSpPr>
@@ -11879,7 +11964,7 @@
       </p:sp>
       <p:sp>
         <p:nvSpPr>
-          <p:cNvPr id="79" name="Text 77"/>
+          <p:cNvPr id="80" name="Text 78"/>
           <p:cNvSpPr/>
           <p:nvPr/>
         </p:nvSpPr>
@@ -13062,7 +13147,7 @@
         <p:spPr>
           <a:xfrm>
             <a:off x="4599432" y="3314700"/>
-            <a:ext cx="763524" cy="400050"/>
+            <a:ext cx="315468" cy="400050"/>
           </a:xfrm>
           <a:prstGeom prst="rect">
             <a:avLst/>
@@ -13086,7 +13171,7 @@
                 <a:ea typeface="Microsoft JhengHei" pitchFamily="34" charset="-122"/>
                 <a:cs typeface="Microsoft JhengHei" pitchFamily="34" charset="-120"/>
               </a:rPr>
-              <a:t>② 1 / </a:t>
+              <a:t>② </a:t>
             </a:r>
             <a:endParaRPr lang="en-US" sz="2100" dirty="0"/>
           </a:p>
@@ -13094,30 +13179,53 @@
       </p:sp>
       <p:sp>
         <p:nvSpPr>
-          <p:cNvPr id="37" name="Text 35"/>
-          <p:cNvSpPr/>
-          <p:nvPr/>
-        </p:nvSpPr>
-        <p:spPr>
-          <a:xfrm>
-            <a:off x="5362956" y="3261360"/>
-            <a:ext cx="184252" cy="208026"/>
-          </a:xfrm>
-          <a:prstGeom prst="rect">
-            <a:avLst/>
-          </a:prstGeom>
-          <a:noFill/>
-          <a:ln/>
-        </p:spPr>
-        <p:txBody>
-          <a:bodyPr wrap="none" lIns="0" tIns="0" rIns="0" bIns="0" rtlCol="0" anchor="ctr"/>
-          <a:lstStyle/>
-          <a:p>
-            <a:pPr algn="ctr" indent="0" marL="0">
-              <a:buNone/>
-            </a:pPr>
-            <a:r>
-              <a:rPr lang="en-US" sz="1260" b="1" dirty="0">
+          <p:cNvPr id="37" name="Shape 35"/>
+          <p:cNvSpPr/>
+          <p:nvPr/>
+        </p:nvSpPr>
+        <p:spPr>
+          <a:xfrm>
+            <a:off x="4960620" y="3514725"/>
+            <a:ext cx="766400" cy="0"/>
+          </a:xfrm>
+          <a:prstGeom prst="line">
+            <a:avLst/>
+          </a:prstGeom>
+          <a:noFill/>
+          <a:ln w="28575">
+            <a:solidFill>
+              <a:srgbClr val="202A26"/>
+            </a:solidFill>
+            <a:prstDash val="solid"/>
+          </a:ln>
+        </p:spPr>
+      </p:sp>
+      <p:sp>
+        <p:nvSpPr>
+          <p:cNvPr id="38" name="Text 36"/>
+          <p:cNvSpPr/>
+          <p:nvPr/>
+        </p:nvSpPr>
+        <p:spPr>
+          <a:xfrm>
+            <a:off x="5230038" y="3179110"/>
+            <a:ext cx="227564" cy="352044"/>
+          </a:xfrm>
+          <a:prstGeom prst="rect">
+            <a:avLst/>
+          </a:prstGeom>
+          <a:noFill/>
+          <a:ln/>
+        </p:spPr>
+        <p:txBody>
+          <a:bodyPr wrap="none" lIns="0" tIns="0" rIns="0" bIns="0" rtlCol="0" anchor="ctr"/>
+          <a:lstStyle/>
+          <a:p>
+            <a:pPr algn="ctr" indent="0" marL="0">
+              <a:buNone/>
+            </a:pPr>
+            <a:r>
+              <a:rPr lang="en-US" sz="1848" b="1" dirty="0">
                 <a:solidFill>
                   <a:srgbClr val="202A26"/>
                 </a:solidFill>
@@ -13125,22 +13233,61 @@
                 <a:ea typeface="Microsoft JhengHei" pitchFamily="34" charset="-122"/>
                 <a:cs typeface="Microsoft JhengHei" pitchFamily="34" charset="-120"/>
               </a:rPr>
+              <a:t>1</a:t>
+            </a:r>
+            <a:endParaRPr lang="en-US" sz="1848" dirty="0"/>
+          </a:p>
+        </p:txBody>
+      </p:sp>
+      <p:sp>
+        <p:nvSpPr>
+          <p:cNvPr id="39" name="Text 37"/>
+          <p:cNvSpPr/>
+          <p:nvPr/>
+        </p:nvSpPr>
+        <p:spPr>
+          <a:xfrm>
+            <a:off x="4988052" y="3560445"/>
+            <a:ext cx="173114" cy="183063"/>
+          </a:xfrm>
+          <a:prstGeom prst="rect">
+            <a:avLst/>
+          </a:prstGeom>
+          <a:noFill/>
+          <a:ln/>
+        </p:spPr>
+        <p:txBody>
+          <a:bodyPr wrap="none" lIns="0" tIns="0" rIns="0" bIns="0" rtlCol="0" anchor="ctr"/>
+          <a:lstStyle/>
+          <a:p>
+            <a:pPr algn="ctr" indent="0" marL="0">
+              <a:buNone/>
+            </a:pPr>
+            <a:r>
+              <a:rPr lang="en-US" sz="1109" b="1" dirty="0">
+                <a:solidFill>
+                  <a:srgbClr val="202A26"/>
+                </a:solidFill>
+                <a:latin typeface="Microsoft JhengHei" pitchFamily="34" charset="0"/>
+                <a:ea typeface="Microsoft JhengHei" pitchFamily="34" charset="-122"/>
+                <a:cs typeface="Microsoft JhengHei" pitchFamily="34" charset="-120"/>
+              </a:rPr>
               <a:t>3</a:t>
             </a:r>
-            <a:endParaRPr lang="en-US" sz="1260" dirty="0"/>
-          </a:p>
-        </p:txBody>
-      </p:sp>
-      <p:sp>
-        <p:nvSpPr>
-          <p:cNvPr id="38" name="Shape 36"/>
-          <p:cNvSpPr/>
-          <p:nvPr/>
-        </p:nvSpPr>
-        <p:spPr>
-          <a:xfrm>
-            <a:off x="5537995" y="3509391"/>
-            <a:ext cx="46619" cy="80010"/>
+            <a:endParaRPr lang="en-US" sz="1109" dirty="0"/>
+          </a:p>
+        </p:txBody>
+      </p:sp>
+      <p:sp>
+        <p:nvSpPr>
+          <p:cNvPr id="40" name="Shape 38"/>
+          <p:cNvSpPr/>
+          <p:nvPr/>
+        </p:nvSpPr>
+        <p:spPr>
+          <a:xfrm>
+            <a:off x="5152510" y="3778712"/>
+            <a:ext cx="41025" cy="70409"/>
           </a:xfrm>
           <a:prstGeom prst="line">
             <a:avLst/>
@@ -13156,14 +13303,14 @@
       </p:sp>
       <p:sp>
         <p:nvSpPr>
-          <p:cNvPr id="39" name="Shape 37"/>
+          <p:cNvPr id="41" name="Shape 39"/>
           <p:cNvSpPr/>
           <p:nvPr/>
         </p:nvSpPr>
         <p:spPr>
           <a:xfrm flipV="1">
-            <a:off x="5584614" y="3308833"/>
-            <a:ext cx="76063" cy="280568"/>
+            <a:off x="5193535" y="3602221"/>
+            <a:ext cx="66935" cy="246900"/>
           </a:xfrm>
           <a:prstGeom prst="line">
             <a:avLst/>
@@ -13179,14 +13326,14 @@
       </p:sp>
       <p:sp>
         <p:nvSpPr>
-          <p:cNvPr id="40" name="Shape 38"/>
-          <p:cNvSpPr/>
-          <p:nvPr/>
-        </p:nvSpPr>
-        <p:spPr>
-          <a:xfrm>
-            <a:off x="5660677" y="3308833"/>
-            <a:ext cx="447566" cy="0"/>
+          <p:cNvPr id="42" name="Shape 40"/>
+          <p:cNvSpPr/>
+          <p:nvPr/>
+        </p:nvSpPr>
+        <p:spPr>
+          <a:xfrm>
+            <a:off x="5260471" y="3602221"/>
+            <a:ext cx="418876" cy="0"/>
           </a:xfrm>
           <a:prstGeom prst="line">
             <a:avLst/>
@@ -13202,14 +13349,92 @@
       </p:sp>
       <p:sp>
         <p:nvSpPr>
-          <p:cNvPr id="41" name="Text 39"/>
-          <p:cNvSpPr/>
-          <p:nvPr/>
-        </p:nvSpPr>
-        <p:spPr>
-          <a:xfrm>
-            <a:off x="5678965" y="3314700"/>
-            <a:ext cx="246126" cy="400050"/>
+          <p:cNvPr id="43" name="Text 41"/>
+          <p:cNvSpPr/>
+          <p:nvPr/>
+        </p:nvSpPr>
+        <p:spPr>
+          <a:xfrm>
+            <a:off x="5278759" y="3607384"/>
+            <a:ext cx="227564" cy="352044"/>
+          </a:xfrm>
+          <a:prstGeom prst="rect">
+            <a:avLst/>
+          </a:prstGeom>
+          <a:noFill/>
+          <a:ln/>
+        </p:spPr>
+        <p:txBody>
+          <a:bodyPr wrap="none" lIns="0" tIns="0" rIns="0" bIns="0" rtlCol="0" anchor="ctr"/>
+          <a:lstStyle/>
+          <a:p>
+            <a:pPr algn="ctr" indent="0" marL="0">
+              <a:buNone/>
+            </a:pPr>
+            <a:r>
+              <a:rPr lang="en-US" sz="1848" b="1" dirty="0">
+                <a:solidFill>
+                  <a:srgbClr val="202A26"/>
+                </a:solidFill>
+                <a:latin typeface="Microsoft JhengHei" pitchFamily="34" charset="0"/>
+                <a:ea typeface="Microsoft JhengHei" pitchFamily="34" charset="-122"/>
+                <a:cs typeface="Microsoft JhengHei" pitchFamily="34" charset="-120"/>
+              </a:rPr>
+              <a:t>a</a:t>
+            </a:r>
+            <a:endParaRPr lang="en-US" sz="1848" dirty="0"/>
+          </a:p>
+        </p:txBody>
+      </p:sp>
+      <p:sp>
+        <p:nvSpPr>
+          <p:cNvPr id="44" name="Text 42"/>
+          <p:cNvSpPr/>
+          <p:nvPr/>
+        </p:nvSpPr>
+        <p:spPr>
+          <a:xfrm>
+            <a:off x="5481705" y="3580394"/>
+            <a:ext cx="175837" cy="218267"/>
+          </a:xfrm>
+          <a:prstGeom prst="rect">
+            <a:avLst/>
+          </a:prstGeom>
+          <a:noFill/>
+          <a:ln/>
+        </p:spPr>
+        <p:txBody>
+          <a:bodyPr wrap="none" lIns="0" tIns="0" rIns="0" bIns="0" rtlCol="0" anchor="ctr"/>
+          <a:lstStyle/>
+          <a:p>
+            <a:pPr algn="ctr" indent="0" marL="0">
+              <a:buNone/>
+            </a:pPr>
+            <a:r>
+              <a:rPr lang="en-US" sz="1146" b="1" dirty="0">
+                <a:solidFill>
+                  <a:srgbClr val="202A26"/>
+                </a:solidFill>
+                <a:latin typeface="Microsoft JhengHei" pitchFamily="34" charset="0"/>
+                <a:ea typeface="Microsoft JhengHei" pitchFamily="34" charset="-122"/>
+                <a:cs typeface="Microsoft JhengHei" pitchFamily="34" charset="-120"/>
+              </a:rPr>
+              <a:t>5</a:t>
+            </a:r>
+            <a:endParaRPr lang="en-US" sz="1146" dirty="0"/>
+          </a:p>
+        </p:txBody>
+      </p:sp>
+      <p:sp>
+        <p:nvSpPr>
+          <p:cNvPr id="45" name="Text 43"/>
+          <p:cNvSpPr/>
+          <p:nvPr/>
+        </p:nvSpPr>
+        <p:spPr>
+          <a:xfrm>
+            <a:off x="5772740" y="3314700"/>
+            <a:ext cx="539496" cy="400050"/>
           </a:xfrm>
           <a:prstGeom prst="rect">
             <a:avLst/>
@@ -13233,7 +13458,7 @@
                 <a:ea typeface="Microsoft JhengHei" pitchFamily="34" charset="-122"/>
                 <a:cs typeface="Microsoft JhengHei" pitchFamily="34" charset="-120"/>
               </a:rPr>
-              <a:t>a</a:t>
+              <a:t> = ?</a:t>
             </a:r>
             <a:endParaRPr lang="en-US" sz="2100" dirty="0"/>
           </a:p>
@@ -13241,85 +13466,7 @@
       </p:sp>
       <p:sp>
         <p:nvSpPr>
-          <p:cNvPr id="42" name="Text 40"/>
-          <p:cNvSpPr/>
-          <p:nvPr/>
-        </p:nvSpPr>
-        <p:spPr>
-          <a:xfrm>
-            <a:off x="5898863" y="3284030"/>
-            <a:ext cx="187345" cy="248031"/>
-          </a:xfrm>
-          <a:prstGeom prst="rect">
-            <a:avLst/>
-          </a:prstGeom>
-          <a:noFill/>
-          <a:ln/>
-        </p:spPr>
-        <p:txBody>
-          <a:bodyPr wrap="none" lIns="0" tIns="0" rIns="0" bIns="0" rtlCol="0" anchor="ctr"/>
-          <a:lstStyle/>
-          <a:p>
-            <a:pPr algn="ctr" indent="0" marL="0">
-              <a:buNone/>
-            </a:pPr>
-            <a:r>
-              <a:rPr lang="en-US" sz="1302" b="1" dirty="0">
-                <a:solidFill>
-                  <a:srgbClr val="202A26"/>
-                </a:solidFill>
-                <a:latin typeface="Microsoft JhengHei" pitchFamily="34" charset="0"/>
-                <a:ea typeface="Microsoft JhengHei" pitchFamily="34" charset="-122"/>
-                <a:cs typeface="Microsoft JhengHei" pitchFamily="34" charset="-120"/>
-              </a:rPr>
-              <a:t>5</a:t>
-            </a:r>
-            <a:endParaRPr lang="en-US" sz="1302" dirty="0"/>
-          </a:p>
-        </p:txBody>
-      </p:sp>
-      <p:sp>
-        <p:nvSpPr>
-          <p:cNvPr id="43" name="Text 41"/>
-          <p:cNvSpPr/>
-          <p:nvPr/>
-        </p:nvSpPr>
-        <p:spPr>
-          <a:xfrm>
-            <a:off x="6126257" y="3314700"/>
-            <a:ext cx="539496" cy="400050"/>
-          </a:xfrm>
-          <a:prstGeom prst="rect">
-            <a:avLst/>
-          </a:prstGeom>
-          <a:noFill/>
-          <a:ln/>
-        </p:spPr>
-        <p:txBody>
-          <a:bodyPr wrap="none" lIns="0" tIns="0" rIns="0" bIns="0" rtlCol="0" anchor="ctr"/>
-          <a:lstStyle/>
-          <a:p>
-            <a:pPr algn="ctr" indent="0" marL="0">
-              <a:buNone/>
-            </a:pPr>
-            <a:r>
-              <a:rPr lang="en-US" sz="2100" b="1" dirty="0">
-                <a:solidFill>
-                  <a:srgbClr val="202A26"/>
-                </a:solidFill>
-                <a:latin typeface="Microsoft JhengHei" pitchFamily="34" charset="0"/>
-                <a:ea typeface="Microsoft JhengHei" pitchFamily="34" charset="-122"/>
-                <a:cs typeface="Microsoft JhengHei" pitchFamily="34" charset="-120"/>
-              </a:rPr>
-              <a:t> = ?</a:t>
-            </a:r>
-            <a:endParaRPr lang="en-US" sz="2100" dirty="0"/>
-          </a:p>
-        </p:txBody>
-      </p:sp>
-      <p:sp>
-        <p:nvSpPr>
-          <p:cNvPr id="44" name="Text 42"/>
+          <p:cNvPr id="46" name="Text 44"/>
           <p:cNvSpPr/>
           <p:nvPr/>
         </p:nvSpPr>
@@ -13358,7 +13505,7 @@
       </p:sp>
       <p:sp>
         <p:nvSpPr>
-          <p:cNvPr id="45" name="Shape 43"/>
+          <p:cNvPr id="47" name="Shape 45"/>
           <p:cNvSpPr/>
           <p:nvPr/>
         </p:nvSpPr>
@@ -13381,7 +13528,7 @@
       </p:sp>
       <p:sp>
         <p:nvSpPr>
-          <p:cNvPr id="46" name="Text 44"/>
+          <p:cNvPr id="48" name="Text 46"/>
           <p:cNvSpPr/>
           <p:nvPr/>
         </p:nvSpPr>
@@ -13420,13 +13567,13 @@
       </p:sp>
       <p:sp>
         <p:nvSpPr>
-          <p:cNvPr id="47" name="Text 45"/>
-          <p:cNvSpPr/>
-          <p:nvPr/>
-        </p:nvSpPr>
-        <p:spPr>
-          <a:xfrm>
-            <a:off x="4988052" y="4298396"/>
+          <p:cNvPr id="49" name="Text 47"/>
+          <p:cNvSpPr/>
+          <p:nvPr/>
+        </p:nvSpPr>
+        <p:spPr>
+          <a:xfrm>
+            <a:off x="4988052" y="4325341"/>
             <a:ext cx="227564" cy="352044"/>
           </a:xfrm>
           <a:prstGeom prst="rect">
@@ -13459,7 +13606,7 @@
       </p:sp>
       <p:sp>
         <p:nvSpPr>
-          <p:cNvPr id="48" name="Shape 46"/>
+          <p:cNvPr id="50" name="Shape 48"/>
           <p:cNvSpPr/>
           <p:nvPr/>
         </p:nvSpPr>
@@ -13482,7 +13629,7 @@
       </p:sp>
       <p:sp>
         <p:nvSpPr>
-          <p:cNvPr id="49" name="Text 47"/>
+          <p:cNvPr id="51" name="Text 49"/>
           <p:cNvSpPr/>
           <p:nvPr/>
         </p:nvSpPr>
@@ -13521,13 +13668,13 @@
       </p:sp>
       <p:sp>
         <p:nvSpPr>
-          <p:cNvPr id="50" name="Text 48"/>
-          <p:cNvSpPr/>
-          <p:nvPr/>
-        </p:nvSpPr>
-        <p:spPr>
-          <a:xfrm>
-            <a:off x="5316820" y="4197959"/>
+          <p:cNvPr id="52" name="Text 50"/>
+          <p:cNvSpPr/>
+          <p:nvPr/>
+        </p:nvSpPr>
+        <p:spPr>
+          <a:xfrm>
+            <a:off x="5316820" y="4232038"/>
             <a:ext cx="175837" cy="218267"/>
           </a:xfrm>
           <a:prstGeom prst="rect">
@@ -13560,7 +13707,7 @@
       </p:sp>
       <p:sp>
         <p:nvSpPr>
-          <p:cNvPr id="51" name="Text 49"/>
+          <p:cNvPr id="53" name="Text 51"/>
           <p:cNvSpPr/>
           <p:nvPr/>
         </p:nvSpPr>
@@ -13599,7 +13746,7 @@
       </p:sp>
       <p:sp>
         <p:nvSpPr>
-          <p:cNvPr id="52" name="Shape 50"/>
+          <p:cNvPr id="54" name="Shape 52"/>
           <p:cNvSpPr/>
           <p:nvPr/>
         </p:nvSpPr>
@@ -13626,7 +13773,7 @@
       </p:sp>
       <p:sp>
         <p:nvSpPr>
-          <p:cNvPr id="53" name="Shape 51"/>
+          <p:cNvPr id="55" name="Shape 53"/>
           <p:cNvSpPr/>
           <p:nvPr/>
         </p:nvSpPr>
@@ -13648,7 +13795,7 @@
       </p:sp>
       <p:sp>
         <p:nvSpPr>
-          <p:cNvPr id="54" name="Text 52"/>
+          <p:cNvPr id="56" name="Text 54"/>
           <p:cNvSpPr/>
           <p:nvPr/>
         </p:nvSpPr>
@@ -13687,7 +13834,7 @@
       </p:sp>
       <p:sp>
         <p:nvSpPr>
-          <p:cNvPr id="55" name="Text 53"/>
+          <p:cNvPr id="57" name="Text 55"/>
           <p:cNvSpPr/>
           <p:nvPr/>
         </p:nvSpPr>
@@ -13726,7 +13873,7 @@
       </p:sp>
       <p:sp>
         <p:nvSpPr>
-          <p:cNvPr id="56" name="Text 54"/>
+          <p:cNvPr id="58" name="Text 56"/>
           <p:cNvSpPr/>
           <p:nvPr/>
         </p:nvSpPr>
@@ -13765,7 +13912,7 @@
       </p:sp>
       <p:sp>
         <p:nvSpPr>
-          <p:cNvPr id="57" name="Text 55"/>
+          <p:cNvPr id="59" name="Text 57"/>
           <p:cNvSpPr/>
           <p:nvPr/>
         </p:nvSpPr>
@@ -13804,7 +13951,7 @@
       </p:sp>
       <p:sp>
         <p:nvSpPr>
-          <p:cNvPr id="58" name="Shape 56"/>
+          <p:cNvPr id="60" name="Shape 58"/>
           <p:cNvSpPr/>
           <p:nvPr/>
         </p:nvSpPr>
@@ -13827,7 +13974,7 @@
       </p:sp>
       <p:sp>
         <p:nvSpPr>
-          <p:cNvPr id="59" name="Shape 57"/>
+          <p:cNvPr id="61" name="Shape 59"/>
           <p:cNvSpPr/>
           <p:nvPr/>
         </p:nvSpPr>
@@ -13850,7 +13997,7 @@
       </p:sp>
       <p:sp>
         <p:nvSpPr>
-          <p:cNvPr id="60" name="Shape 58"/>
+          <p:cNvPr id="62" name="Shape 60"/>
           <p:cNvSpPr/>
           <p:nvPr/>
         </p:nvSpPr>
@@ -13873,7 +14020,7 @@
       </p:sp>
       <p:sp>
         <p:nvSpPr>
-          <p:cNvPr id="61" name="Text 59"/>
+          <p:cNvPr id="63" name="Text 61"/>
           <p:cNvSpPr/>
           <p:nvPr/>
         </p:nvSpPr>
@@ -13912,7 +14059,7 @@
       </p:sp>
       <p:sp>
         <p:nvSpPr>
-          <p:cNvPr id="62" name="Text 60"/>
+          <p:cNvPr id="64" name="Text 62"/>
           <p:cNvSpPr/>
           <p:nvPr/>
         </p:nvSpPr>
@@ -13951,7 +14098,7 @@
       </p:sp>
       <p:sp>
         <p:nvSpPr>
-          <p:cNvPr id="63" name="Text 61"/>
+          <p:cNvPr id="65" name="Text 63"/>
           <p:cNvSpPr/>
           <p:nvPr/>
         </p:nvSpPr>
@@ -13990,7 +14137,7 @@
       </p:sp>
       <p:sp>
         <p:nvSpPr>
-          <p:cNvPr id="64" name="Shape 62"/>
+          <p:cNvPr id="66" name="Shape 64"/>
           <p:cNvSpPr/>
           <p:nvPr/>
         </p:nvSpPr>
@@ -14013,7 +14160,7 @@
       </p:sp>
       <p:sp>
         <p:nvSpPr>
-          <p:cNvPr id="65" name="Shape 63"/>
+          <p:cNvPr id="67" name="Shape 65"/>
           <p:cNvSpPr/>
           <p:nvPr/>
         </p:nvSpPr>
@@ -14036,7 +14183,7 @@
       </p:sp>
       <p:sp>
         <p:nvSpPr>
-          <p:cNvPr id="66" name="Shape 64"/>
+          <p:cNvPr id="68" name="Shape 66"/>
           <p:cNvSpPr/>
           <p:nvPr/>
         </p:nvSpPr>
@@ -14059,7 +14206,7 @@
       </p:sp>
       <p:sp>
         <p:nvSpPr>
-          <p:cNvPr id="67" name="Text 65"/>
+          <p:cNvPr id="69" name="Text 67"/>
           <p:cNvSpPr/>
           <p:nvPr/>
         </p:nvSpPr>
@@ -14098,7 +14245,7 @@
       </p:sp>
       <p:sp>
         <p:nvSpPr>
-          <p:cNvPr id="68" name="Text 66"/>
+          <p:cNvPr id="70" name="Text 68"/>
           <p:cNvSpPr/>
           <p:nvPr/>
         </p:nvSpPr>
@@ -14137,7 +14284,7 @@
       </p:sp>
       <p:sp>
         <p:nvSpPr>
-          <p:cNvPr id="69" name="Text 67"/>
+          <p:cNvPr id="71" name="Text 69"/>
           <p:cNvSpPr/>
           <p:nvPr/>
         </p:nvSpPr>
@@ -14176,7 +14323,7 @@
       </p:sp>
       <p:sp>
         <p:nvSpPr>
-          <p:cNvPr id="70" name="Text 68"/>
+          <p:cNvPr id="72" name="Text 70"/>
           <p:cNvSpPr/>
           <p:nvPr/>
         </p:nvSpPr>
@@ -14215,7 +14362,7 @@
       </p:sp>
       <p:sp>
         <p:nvSpPr>
-          <p:cNvPr id="71" name="Shape 69"/>
+          <p:cNvPr id="73" name="Shape 71"/>
           <p:cNvSpPr/>
           <p:nvPr/>
         </p:nvSpPr>
@@ -14242,7 +14389,7 @@
       </p:sp>
       <p:sp>
         <p:nvSpPr>
-          <p:cNvPr id="72" name="Text 70"/>
+          <p:cNvPr id="74" name="Text 72"/>
           <p:cNvSpPr/>
           <p:nvPr/>
         </p:nvSpPr>
@@ -14696,7 +14843,7 @@
         </p:nvSpPr>
         <p:spPr>
           <a:xfrm>
-            <a:off x="2050455" y="2353007"/>
+            <a:off x="2050455" y="2387641"/>
             <a:ext cx="171818" cy="207874"/>
           </a:xfrm>
           <a:prstGeom prst="rect">
@@ -14875,7 +15022,7 @@
         </p:nvSpPr>
         <p:spPr>
           <a:xfrm>
-            <a:off x="2940002" y="2353007"/>
+            <a:off x="2940002" y="2387641"/>
             <a:ext cx="171818" cy="207874"/>
           </a:xfrm>
           <a:prstGeom prst="rect">
@@ -15054,7 +15201,7 @@
         </p:nvSpPr>
         <p:spPr>
           <a:xfrm>
-            <a:off x="3829549" y="2353007"/>
+            <a:off x="3829549" y="2387641"/>
             <a:ext cx="171818" cy="207874"/>
           </a:xfrm>
           <a:prstGeom prst="rect">
@@ -15333,7 +15480,7 @@
         </p:nvSpPr>
         <p:spPr>
           <a:xfrm>
-            <a:off x="2050455" y="3944063"/>
+            <a:off x="2050455" y="3978697"/>
             <a:ext cx="171818" cy="207874"/>
           </a:xfrm>
           <a:prstGeom prst="rect">
@@ -15512,7 +15659,7 @@
         </p:nvSpPr>
         <p:spPr>
           <a:xfrm>
-            <a:off x="2940002" y="3944063"/>
+            <a:off x="2940002" y="3978697"/>
             <a:ext cx="171818" cy="207874"/>
           </a:xfrm>
           <a:prstGeom prst="rect">
@@ -15691,7 +15838,7 @@
         </p:nvSpPr>
         <p:spPr>
           <a:xfrm>
-            <a:off x="3829549" y="3944063"/>
+            <a:off x="3829549" y="3978697"/>
             <a:ext cx="171818" cy="207874"/>
           </a:xfrm>
           <a:prstGeom prst="rect">
@@ -16087,7 +16234,7 @@
         </p:nvSpPr>
         <p:spPr>
           <a:xfrm>
-            <a:off x="2688820" y="5535119"/>
+            <a:off x="2688820" y="5569753"/>
             <a:ext cx="171818" cy="207874"/>
           </a:xfrm>
           <a:prstGeom prst="rect">
@@ -16204,8 +16351,8 @@
         </p:nvSpPr>
         <p:spPr>
           <a:xfrm>
-            <a:off x="3461549" y="5426710"/>
-            <a:ext cx="630022" cy="236220"/>
+            <a:off x="3455374" y="5426710"/>
+            <a:ext cx="356006" cy="236220"/>
           </a:xfrm>
           <a:prstGeom prst="rect">
             <a:avLst/>
@@ -16229,7 +16376,7 @@
                 <a:ea typeface="Microsoft JhengHei" pitchFamily="34" charset="-122"/>
                 <a:cs typeface="Microsoft JhengHei" pitchFamily="34" charset="-120"/>
               </a:rPr>
-              <a:t>3 × 2/3</a:t>
+              <a:t>3 × </a:t>
             </a:r>
             <a:endParaRPr lang="en-US" sz="1240" dirty="0"/>
           </a:p>
@@ -16237,13 +16384,114 @@
       </p:sp>
       <p:sp>
         <p:nvSpPr>
-          <p:cNvPr id="56" name="Text 54"/>
-          <p:cNvSpPr/>
-          <p:nvPr/>
-        </p:nvSpPr>
-        <p:spPr>
-          <a:xfrm>
-            <a:off x="4104171" y="5455920"/>
+          <p:cNvPr id="56" name="Shape 54"/>
+          <p:cNvSpPr/>
+          <p:nvPr/>
+        </p:nvSpPr>
+        <p:spPr>
+          <a:xfrm>
+            <a:off x="3857101" y="5544820"/>
+            <a:ext cx="226682" cy="0"/>
+          </a:xfrm>
+          <a:prstGeom prst="line">
+            <a:avLst/>
+          </a:prstGeom>
+          <a:noFill/>
+          <a:ln w="28575">
+            <a:solidFill>
+              <a:srgbClr val="4E5C55"/>
+            </a:solidFill>
+            <a:prstDash val="solid"/>
+          </a:ln>
+        </p:spPr>
+      </p:sp>
+      <p:sp>
+        <p:nvSpPr>
+          <p:cNvPr id="57" name="Text 55"/>
+          <p:cNvSpPr/>
+          <p:nvPr/>
+        </p:nvSpPr>
+        <p:spPr>
+          <a:xfrm>
+            <a:off x="3884533" y="5346647"/>
+            <a:ext cx="171818" cy="207874"/>
+          </a:xfrm>
+          <a:prstGeom prst="rect">
+            <a:avLst/>
+          </a:prstGeom>
+          <a:noFill/>
+          <a:ln/>
+        </p:spPr>
+        <p:txBody>
+          <a:bodyPr wrap="none" lIns="0" tIns="0" rIns="0" bIns="0" rtlCol="0" anchor="ctr"/>
+          <a:lstStyle/>
+          <a:p>
+            <a:pPr algn="ctr" indent="0" marL="0">
+              <a:buNone/>
+            </a:pPr>
+            <a:r>
+              <a:rPr lang="en-US" sz="1091" b="1" dirty="0">
+                <a:solidFill>
+                  <a:srgbClr val="4E5C55"/>
+                </a:solidFill>
+                <a:latin typeface="Microsoft JhengHei" pitchFamily="34" charset="0"/>
+                <a:ea typeface="Microsoft JhengHei" pitchFamily="34" charset="-122"/>
+                <a:cs typeface="Microsoft JhengHei" pitchFamily="34" charset="-120"/>
+              </a:rPr>
+              <a:t>2</a:t>
+            </a:r>
+            <a:endParaRPr lang="en-US" sz="1091" dirty="0"/>
+          </a:p>
+        </p:txBody>
+      </p:sp>
+      <p:sp>
+        <p:nvSpPr>
+          <p:cNvPr id="58" name="Text 56"/>
+          <p:cNvSpPr/>
+          <p:nvPr/>
+        </p:nvSpPr>
+        <p:spPr>
+          <a:xfrm>
+            <a:off x="3884533" y="5569753"/>
+            <a:ext cx="171818" cy="207874"/>
+          </a:xfrm>
+          <a:prstGeom prst="rect">
+            <a:avLst/>
+          </a:prstGeom>
+          <a:noFill/>
+          <a:ln/>
+        </p:spPr>
+        <p:txBody>
+          <a:bodyPr wrap="none" lIns="0" tIns="0" rIns="0" bIns="0" rtlCol="0" anchor="ctr"/>
+          <a:lstStyle/>
+          <a:p>
+            <a:pPr algn="ctr" indent="0" marL="0">
+              <a:buNone/>
+            </a:pPr>
+            <a:r>
+              <a:rPr lang="en-US" sz="1091" b="1" dirty="0">
+                <a:solidFill>
+                  <a:srgbClr val="4E5C55"/>
+                </a:solidFill>
+                <a:latin typeface="Microsoft JhengHei" pitchFamily="34" charset="0"/>
+                <a:ea typeface="Microsoft JhengHei" pitchFamily="34" charset="-122"/>
+                <a:cs typeface="Microsoft JhengHei" pitchFamily="34" charset="-120"/>
+              </a:rPr>
+              <a:t>3</a:t>
+            </a:r>
+            <a:endParaRPr lang="en-US" sz="1091" dirty="0"/>
+          </a:p>
+        </p:txBody>
+      </p:sp>
+      <p:sp>
+        <p:nvSpPr>
+          <p:cNvPr id="59" name="Text 57"/>
+          <p:cNvSpPr/>
+          <p:nvPr/>
+        </p:nvSpPr>
+        <p:spPr>
+          <a:xfrm>
+            <a:off x="4142985" y="5455920"/>
             <a:ext cx="370840" cy="381000"/>
           </a:xfrm>
           <a:prstGeom prst="rect">
@@ -16276,13 +16524,13 @@
       </p:sp>
       <p:sp>
         <p:nvSpPr>
-          <p:cNvPr id="57" name="Text 55"/>
-          <p:cNvSpPr/>
-          <p:nvPr/>
-        </p:nvSpPr>
-        <p:spPr>
-          <a:xfrm>
-            <a:off x="4475011" y="5455920"/>
+          <p:cNvPr id="60" name="Text 58"/>
+          <p:cNvSpPr/>
+          <p:nvPr/>
+        </p:nvSpPr>
+        <p:spPr>
+          <a:xfrm>
+            <a:off x="4513825" y="5455920"/>
             <a:ext cx="238760" cy="381000"/>
           </a:xfrm>
           <a:prstGeom prst="rect">
@@ -16315,13 +16563,13 @@
       </p:sp>
       <p:sp>
         <p:nvSpPr>
-          <p:cNvPr id="58" name="Text 56"/>
-          <p:cNvSpPr/>
-          <p:nvPr/>
-        </p:nvSpPr>
-        <p:spPr>
-          <a:xfrm>
-            <a:off x="4688182" y="5426710"/>
+          <p:cNvPr id="61" name="Text 59"/>
+          <p:cNvSpPr/>
+          <p:nvPr/>
+        </p:nvSpPr>
+        <p:spPr>
+          <a:xfrm>
+            <a:off x="4726996" y="5426710"/>
             <a:ext cx="182778" cy="236220"/>
           </a:xfrm>
           <a:prstGeom prst="rect">
@@ -16986,7 +17234,7 @@
         </p:nvSpPr>
         <p:spPr>
           <a:xfrm>
-            <a:off x="8389478" y="2283434"/>
+            <a:off x="8389478" y="2317513"/>
             <a:ext cx="175837" cy="218267"/>
           </a:xfrm>
           <a:prstGeom prst="rect">
@@ -17282,7 +17530,7 @@
         </p:nvSpPr>
         <p:spPr>
           <a:xfrm>
-            <a:off x="9961014" y="2283434"/>
+            <a:off x="9961014" y="2317513"/>
             <a:ext cx="175837" cy="218267"/>
           </a:xfrm>
           <a:prstGeom prst="rect">
@@ -17508,7 +17756,7 @@
         </p:nvSpPr>
         <p:spPr>
           <a:xfrm>
-            <a:off x="5081778" y="4532711"/>
+            <a:off x="5081778" y="4559656"/>
             <a:ext cx="227564" cy="352044"/>
           </a:xfrm>
           <a:prstGeom prst="rect">
@@ -18279,7 +18527,7 @@
         <p:spPr>
           <a:xfrm>
             <a:off x="3202502" y="1670304"/>
-            <a:ext cx="1292352" cy="457200"/>
+            <a:ext cx="426720" cy="457200"/>
           </a:xfrm>
           <a:prstGeom prst="rect">
             <a:avLst/>
@@ -18303,7 +18551,7 @@
                 <a:ea typeface="Microsoft JhengHei" pitchFamily="34" charset="-122"/>
                 <a:cs typeface="Microsoft JhengHei" pitchFamily="34" charset="-120"/>
               </a:rPr>
-              <a:t> = 1 / (3</a:t>
+              <a:t> = </a:t>
             </a:r>
             <a:endParaRPr lang="en-US" sz="2400" dirty="0"/>
           </a:p>
@@ -18311,30 +18559,53 @@
       </p:sp>
       <p:sp>
         <p:nvSpPr>
-          <p:cNvPr id="14" name="Text 12"/>
-          <p:cNvSpPr/>
-          <p:nvPr/>
-        </p:nvSpPr>
-        <p:spPr>
-          <a:xfrm>
-            <a:off x="4494854" y="1670304"/>
-            <a:ext cx="268224" cy="457200"/>
-          </a:xfrm>
-          <a:prstGeom prst="rect">
-            <a:avLst/>
-          </a:prstGeom>
-          <a:noFill/>
-          <a:ln/>
-        </p:spPr>
-        <p:txBody>
-          <a:bodyPr wrap="none" lIns="0" tIns="0" rIns="0" bIns="0" rtlCol="0" anchor="ctr"/>
-          <a:lstStyle/>
-          <a:p>
-            <a:pPr algn="ctr" indent="0" marL="0">
-              <a:buNone/>
-            </a:pPr>
-            <a:r>
-              <a:rPr lang="en-US" sz="2400" b="1" dirty="0">
+          <p:cNvPr id="14" name="Shape 12"/>
+          <p:cNvSpPr/>
+          <p:nvPr/>
+        </p:nvSpPr>
+        <p:spPr>
+          <a:xfrm>
+            <a:off x="3674942" y="1898904"/>
+            <a:ext cx="714230" cy="0"/>
+          </a:xfrm>
+          <a:prstGeom prst="line">
+            <a:avLst/>
+          </a:prstGeom>
+          <a:noFill/>
+          <a:ln w="28575">
+            <a:solidFill>
+              <a:srgbClr val="202A26"/>
+            </a:solidFill>
+            <a:prstDash val="solid"/>
+          </a:ln>
+        </p:spPr>
+      </p:sp>
+      <p:sp>
+        <p:nvSpPr>
+          <p:cNvPr id="15" name="Text 13"/>
+          <p:cNvSpPr/>
+          <p:nvPr/>
+        </p:nvSpPr>
+        <p:spPr>
+          <a:xfrm>
+            <a:off x="3908552" y="1515344"/>
+            <a:ext cx="247010" cy="402336"/>
+          </a:xfrm>
+          <a:prstGeom prst="rect">
+            <a:avLst/>
+          </a:prstGeom>
+          <a:noFill/>
+          <a:ln/>
+        </p:spPr>
+        <p:txBody>
+          <a:bodyPr wrap="none" lIns="0" tIns="0" rIns="0" bIns="0" rtlCol="0" anchor="ctr"/>
+          <a:lstStyle/>
+          <a:p>
+            <a:pPr algn="ctr" indent="0" marL="0">
+              <a:buNone/>
+            </a:pPr>
+            <a:r>
+              <a:rPr lang="en-US" sz="2112" b="1" dirty="0">
                 <a:solidFill>
                   <a:srgbClr val="202A26"/>
                 </a:solidFill>
@@ -18342,38 +18613,116 @@
                 <a:ea typeface="Microsoft JhengHei" pitchFamily="34" charset="-122"/>
                 <a:cs typeface="Microsoft JhengHei" pitchFamily="34" charset="-120"/>
               </a:rPr>
+              <a:t>1</a:t>
+            </a:r>
+            <a:endParaRPr lang="en-US" sz="2112" dirty="0"/>
+          </a:p>
+        </p:txBody>
+      </p:sp>
+      <p:sp>
+        <p:nvSpPr>
+          <p:cNvPr id="16" name="Text 14"/>
+          <p:cNvSpPr/>
+          <p:nvPr/>
+        </p:nvSpPr>
+        <p:spPr>
+          <a:xfrm>
+            <a:off x="3702374" y="1950525"/>
+            <a:ext cx="247010" cy="402336"/>
+          </a:xfrm>
+          <a:prstGeom prst="rect">
+            <a:avLst/>
+          </a:prstGeom>
+          <a:noFill/>
+          <a:ln/>
+        </p:spPr>
+        <p:txBody>
+          <a:bodyPr wrap="none" lIns="0" tIns="0" rIns="0" bIns="0" rtlCol="0" anchor="ctr"/>
+          <a:lstStyle/>
+          <a:p>
+            <a:pPr algn="ctr" indent="0" marL="0">
+              <a:buNone/>
+            </a:pPr>
+            <a:r>
+              <a:rPr lang="en-US" sz="2112" b="1" dirty="0">
+                <a:solidFill>
+                  <a:srgbClr val="202A26"/>
+                </a:solidFill>
+                <a:latin typeface="Microsoft JhengHei" pitchFamily="34" charset="0"/>
+                <a:ea typeface="Microsoft JhengHei" pitchFamily="34" charset="-122"/>
+                <a:cs typeface="Microsoft JhengHei" pitchFamily="34" charset="-120"/>
+              </a:rPr>
+              <a:t>3</a:t>
+            </a:r>
+            <a:endParaRPr lang="en-US" sz="2112" dirty="0"/>
+          </a:p>
+        </p:txBody>
+      </p:sp>
+      <p:sp>
+        <p:nvSpPr>
+          <p:cNvPr id="17" name="Text 15"/>
+          <p:cNvSpPr/>
+          <p:nvPr/>
+        </p:nvSpPr>
+        <p:spPr>
+          <a:xfrm>
+            <a:off x="3949384" y="1950525"/>
+            <a:ext cx="247010" cy="402336"/>
+          </a:xfrm>
+          <a:prstGeom prst="rect">
+            <a:avLst/>
+          </a:prstGeom>
+          <a:noFill/>
+          <a:ln/>
+        </p:spPr>
+        <p:txBody>
+          <a:bodyPr wrap="none" lIns="0" tIns="0" rIns="0" bIns="0" rtlCol="0" anchor="ctr"/>
+          <a:lstStyle/>
+          <a:p>
+            <a:pPr algn="ctr" indent="0" marL="0">
+              <a:buNone/>
+            </a:pPr>
+            <a:r>
+              <a:rPr lang="en-US" sz="2112" b="1" dirty="0">
+                <a:solidFill>
+                  <a:srgbClr val="202A26"/>
+                </a:solidFill>
+                <a:latin typeface="Microsoft JhengHei" pitchFamily="34" charset="0"/>
+                <a:ea typeface="Microsoft JhengHei" pitchFamily="34" charset="-122"/>
+                <a:cs typeface="Microsoft JhengHei" pitchFamily="34" charset="-120"/>
+              </a:rPr>
               <a:t>a</a:t>
             </a:r>
-            <a:endParaRPr lang="en-US" sz="2400" dirty="0"/>
-          </a:p>
-        </p:txBody>
-      </p:sp>
-      <p:sp>
-        <p:nvSpPr>
-          <p:cNvPr id="15" name="Text 13"/>
-          <p:cNvSpPr/>
-          <p:nvPr/>
-        </p:nvSpPr>
-        <p:spPr>
-          <a:xfrm>
-            <a:off x="4734931" y="1635252"/>
-            <a:ext cx="201046" cy="283464"/>
-          </a:xfrm>
-          <a:prstGeom prst="rect">
-            <a:avLst/>
-          </a:prstGeom>
-          <a:noFill/>
-          <a:ln/>
-        </p:spPr>
-        <p:txBody>
-          <a:bodyPr wrap="none" lIns="0" tIns="0" rIns="0" bIns="0" rtlCol="0" anchor="ctr"/>
-          <a:lstStyle/>
-          <a:p>
-            <a:pPr algn="ctr" indent="0" marL="0">
-              <a:buNone/>
-            </a:pPr>
-            <a:r>
-              <a:rPr lang="en-US" sz="1488" b="1" dirty="0">
+            <a:endParaRPr lang="en-US" sz="2112" dirty="0"/>
+          </a:p>
+        </p:txBody>
+      </p:sp>
+      <p:sp>
+        <p:nvSpPr>
+          <p:cNvPr id="18" name="Text 16"/>
+          <p:cNvSpPr/>
+          <p:nvPr/>
+        </p:nvSpPr>
+        <p:spPr>
+          <a:xfrm>
+            <a:off x="4170089" y="1919679"/>
+            <a:ext cx="187893" cy="249448"/>
+          </a:xfrm>
+          <a:prstGeom prst="rect">
+            <a:avLst/>
+          </a:prstGeom>
+          <a:noFill/>
+          <a:ln/>
+        </p:spPr>
+        <p:txBody>
+          <a:bodyPr wrap="none" lIns="0" tIns="0" rIns="0" bIns="0" rtlCol="0" anchor="ctr"/>
+          <a:lstStyle/>
+          <a:p>
+            <a:pPr algn="ctr" indent="0" marL="0">
+              <a:buNone/>
+            </a:pPr>
+            <a:r>
+              <a:rPr lang="en-US" sz="1309" b="1" dirty="0">
                 <a:solidFill>
                   <a:srgbClr val="202A26"/>
                 </a:solidFill>
@@ -18383,75 +18732,36 @@
               </a:rPr>
               <a:t>2</a:t>
             </a:r>
-            <a:endParaRPr lang="en-US" sz="1488" dirty="0"/>
-          </a:p>
-        </p:txBody>
-      </p:sp>
-      <p:sp>
-        <p:nvSpPr>
-          <p:cNvPr id="16" name="Text 14"/>
-          <p:cNvSpPr/>
-          <p:nvPr/>
-        </p:nvSpPr>
-        <p:spPr>
-          <a:xfrm>
-            <a:off x="4939998" y="1670304"/>
-            <a:ext cx="268224" cy="457200"/>
-          </a:xfrm>
-          <a:prstGeom prst="rect">
-            <a:avLst/>
-          </a:prstGeom>
-          <a:noFill/>
-          <a:ln/>
-        </p:spPr>
-        <p:txBody>
-          <a:bodyPr wrap="none" lIns="0" tIns="0" rIns="0" bIns="0" rtlCol="0" anchor="ctr"/>
-          <a:lstStyle/>
-          <a:p>
-            <a:pPr algn="ctr" indent="0" marL="0">
-              <a:buNone/>
-            </a:pPr>
-            <a:r>
-              <a:rPr lang="en-US" sz="2400" b="1" dirty="0">
-                <a:solidFill>
-                  <a:srgbClr val="202A26"/>
-                </a:solidFill>
-                <a:latin typeface="Microsoft JhengHei" pitchFamily="34" charset="0"/>
-                <a:ea typeface="Microsoft JhengHei" pitchFamily="34" charset="-122"/>
-                <a:cs typeface="Microsoft JhengHei" pitchFamily="34" charset="-120"/>
-              </a:rPr>
-              <a:t>)</a:t>
-            </a:r>
-            <a:endParaRPr lang="en-US" sz="2400" dirty="0"/>
-          </a:p>
-        </p:txBody>
-      </p:sp>
-      <p:sp>
-        <p:nvSpPr>
-          <p:cNvPr id="17" name="Text 15"/>
-          <p:cNvSpPr/>
-          <p:nvPr/>
-        </p:nvSpPr>
-        <p:spPr>
-          <a:xfrm>
-            <a:off x="1691640" y="2193463"/>
-            <a:ext cx="9692640" cy="532547"/>
-          </a:xfrm>
-          <a:prstGeom prst="rect">
-            <a:avLst/>
-          </a:prstGeom>
-          <a:noFill/>
-          <a:ln/>
-        </p:spPr>
-        <p:txBody>
-          <a:bodyPr wrap="square" lIns="0" tIns="0" rIns="0" bIns="0" rtlCol="0" anchor="ctr"/>
-          <a:lstStyle/>
-          <a:p>
-            <a:pPr algn="l" indent="0" marL="0">
-              <a:buNone/>
-            </a:pPr>
-            <a:r>
-              <a:rPr lang="en-US" sz="2000" dirty="0">
+            <a:endParaRPr lang="en-US" sz="1309" dirty="0"/>
+          </a:p>
+        </p:txBody>
+      </p:sp>
+      <p:sp>
+        <p:nvSpPr>
+          <p:cNvPr id="19" name="Text 17"/>
+          <p:cNvSpPr/>
+          <p:nvPr/>
+        </p:nvSpPr>
+        <p:spPr>
+          <a:xfrm>
+            <a:off x="1691640" y="2269236"/>
+            <a:ext cx="5247640" cy="381000"/>
+          </a:xfrm>
+          <a:prstGeom prst="rect">
+            <a:avLst/>
+          </a:prstGeom>
+          <a:noFill/>
+          <a:ln/>
+        </p:spPr>
+        <p:txBody>
+          <a:bodyPr wrap="none" lIns="0" tIns="0" rIns="0" bIns="0" rtlCol="0" anchor="ctr"/>
+          <a:lstStyle/>
+          <a:p>
+            <a:pPr algn="ctr" indent="0" marL="0">
+              <a:buNone/>
+            </a:pPr>
+            <a:r>
+              <a:rPr lang="en-US" sz="2000" b="1" dirty="0">
                 <a:solidFill>
                   <a:srgbClr val="4E5C55"/>
                 </a:solidFill>
@@ -18459,13 +18769,61 @@
                 <a:ea typeface="Microsoft JhengHei" pitchFamily="34" charset="-122"/>
                 <a:cs typeface="Microsoft JhengHei" pitchFamily="34" charset="-120"/>
               </a:rPr>
-              <a:t>負指數淨係搬 a，個 3 唔跟住落分母 → 應該係 3 / a</a:t>
-            </a:r>
-            <a:pPr algn="l" indent="0" marL="0">
-              <a:buNone/>
-            </a:pPr>
-            <a:r>
-              <a:rPr lang="en-US" sz="2000" baseline="30000" dirty="0">
+              <a:t>負指數淨係搬 a，個 3 唔跟住落分母 → 應該係 </a:t>
+            </a:r>
+            <a:endParaRPr lang="en-US" sz="2000" dirty="0"/>
+          </a:p>
+        </p:txBody>
+      </p:sp>
+      <p:sp>
+        <p:nvSpPr>
+          <p:cNvPr id="20" name="Shape 18"/>
+          <p:cNvSpPr/>
+          <p:nvPr/>
+        </p:nvSpPr>
+        <p:spPr>
+          <a:xfrm>
+            <a:off x="6985000" y="2459736"/>
+            <a:ext cx="427145" cy="0"/>
+          </a:xfrm>
+          <a:prstGeom prst="line">
+            <a:avLst/>
+          </a:prstGeom>
+          <a:noFill/>
+          <a:ln w="28575">
+            <a:solidFill>
+              <a:srgbClr val="4E5C55"/>
+            </a:solidFill>
+            <a:prstDash val="solid"/>
+          </a:ln>
+        </p:spPr>
+      </p:sp>
+      <p:sp>
+        <p:nvSpPr>
+          <p:cNvPr id="21" name="Text 19"/>
+          <p:cNvSpPr/>
+          <p:nvPr/>
+        </p:nvSpPr>
+        <p:spPr>
+          <a:xfrm>
+            <a:off x="7088032" y="2140102"/>
+            <a:ext cx="221082" cy="335280"/>
+          </a:xfrm>
+          <a:prstGeom prst="rect">
+            <a:avLst/>
+          </a:prstGeom>
+          <a:noFill/>
+          <a:ln/>
+        </p:spPr>
+        <p:txBody>
+          <a:bodyPr wrap="none" lIns="0" tIns="0" rIns="0" bIns="0" rtlCol="0" anchor="ctr"/>
+          <a:lstStyle/>
+          <a:p>
+            <a:pPr algn="ctr" indent="0" marL="0">
+              <a:buNone/>
+            </a:pPr>
+            <a:r>
+              <a:rPr lang="en-US" sz="1760" b="1" dirty="0">
                 <a:solidFill>
                   <a:srgbClr val="4E5C55"/>
                 </a:solidFill>
@@ -18473,15 +18831,93 @@
                 <a:ea typeface="Microsoft JhengHei" pitchFamily="34" charset="-122"/>
                 <a:cs typeface="Microsoft JhengHei" pitchFamily="34" charset="-120"/>
               </a:rPr>
+              <a:t>3</a:t>
+            </a:r>
+            <a:endParaRPr lang="en-US" sz="1760" dirty="0"/>
+          </a:p>
+        </p:txBody>
+      </p:sp>
+      <p:sp>
+        <p:nvSpPr>
+          <p:cNvPr id="22" name="Text 20"/>
+          <p:cNvSpPr/>
+          <p:nvPr/>
+        </p:nvSpPr>
+        <p:spPr>
+          <a:xfrm>
+            <a:off x="7012432" y="2510373"/>
+            <a:ext cx="221082" cy="335280"/>
+          </a:xfrm>
+          <a:prstGeom prst="rect">
+            <a:avLst/>
+          </a:prstGeom>
+          <a:noFill/>
+          <a:ln/>
+        </p:spPr>
+        <p:txBody>
+          <a:bodyPr wrap="none" lIns="0" tIns="0" rIns="0" bIns="0" rtlCol="0" anchor="ctr"/>
+          <a:lstStyle/>
+          <a:p>
+            <a:pPr algn="ctr" indent="0" marL="0">
+              <a:buNone/>
+            </a:pPr>
+            <a:r>
+              <a:rPr lang="en-US" sz="1760" b="1" dirty="0">
+                <a:solidFill>
+                  <a:srgbClr val="4E5C55"/>
+                </a:solidFill>
+                <a:latin typeface="Microsoft JhengHei" pitchFamily="34" charset="0"/>
+                <a:ea typeface="Microsoft JhengHei" pitchFamily="34" charset="-122"/>
+                <a:cs typeface="Microsoft JhengHei" pitchFamily="34" charset="-120"/>
+              </a:rPr>
+              <a:t>a</a:t>
+            </a:r>
+            <a:endParaRPr lang="en-US" sz="1760" dirty="0"/>
+          </a:p>
+        </p:txBody>
+      </p:sp>
+      <p:sp>
+        <p:nvSpPr>
+          <p:cNvPr id="23" name="Text 21"/>
+          <p:cNvSpPr/>
+          <p:nvPr/>
+        </p:nvSpPr>
+        <p:spPr>
+          <a:xfrm>
+            <a:off x="7209459" y="2484669"/>
+            <a:ext cx="171818" cy="207874"/>
+          </a:xfrm>
+          <a:prstGeom prst="rect">
+            <a:avLst/>
+          </a:prstGeom>
+          <a:noFill/>
+          <a:ln/>
+        </p:spPr>
+        <p:txBody>
+          <a:bodyPr wrap="none" lIns="0" tIns="0" rIns="0" bIns="0" rtlCol="0" anchor="ctr"/>
+          <a:lstStyle/>
+          <a:p>
+            <a:pPr algn="ctr" indent="0" marL="0">
+              <a:buNone/>
+            </a:pPr>
+            <a:r>
+              <a:rPr lang="en-US" sz="1091" b="1" dirty="0">
+                <a:solidFill>
+                  <a:srgbClr val="4E5C55"/>
+                </a:solidFill>
+                <a:latin typeface="Microsoft JhengHei" pitchFamily="34" charset="0"/>
+                <a:ea typeface="Microsoft JhengHei" pitchFamily="34" charset="-122"/>
+                <a:cs typeface="Microsoft JhengHei" pitchFamily="34" charset="-120"/>
+              </a:rPr>
               <a:t>2</a:t>
             </a:r>
-            <a:endParaRPr lang="en-US" sz="2000" dirty="0"/>
-          </a:p>
-        </p:txBody>
-      </p:sp>
-      <p:sp>
-        <p:nvSpPr>
-          <p:cNvPr id="18" name="Shape 16"/>
+            <a:endParaRPr lang="en-US" sz="1091" dirty="0"/>
+          </a:p>
+        </p:txBody>
+      </p:sp>
+      <p:sp>
+        <p:nvSpPr>
+          <p:cNvPr id="24" name="Shape 22"/>
           <p:cNvSpPr/>
           <p:nvPr/>
         </p:nvSpPr>
@@ -18508,7 +18944,7 @@
       </p:sp>
       <p:sp>
         <p:nvSpPr>
-          <p:cNvPr id="19" name="Shape 17"/>
+          <p:cNvPr id="25" name="Shape 23"/>
           <p:cNvSpPr/>
           <p:nvPr/>
         </p:nvSpPr>
@@ -18528,7 +18964,7 @@
       </p:sp>
       <p:sp>
         <p:nvSpPr>
-          <p:cNvPr id="20" name="Text 18"/>
+          <p:cNvPr id="26" name="Text 24"/>
           <p:cNvSpPr/>
           <p:nvPr/>
         </p:nvSpPr>
@@ -18567,7 +19003,7 @@
       </p:sp>
       <p:sp>
         <p:nvSpPr>
-          <p:cNvPr id="21" name="Text 19"/>
+          <p:cNvPr id="27" name="Text 25"/>
           <p:cNvSpPr/>
           <p:nvPr/>
         </p:nvSpPr>
@@ -18606,7 +19042,7 @@
       </p:sp>
       <p:sp>
         <p:nvSpPr>
-          <p:cNvPr id="22" name="Text 20"/>
+          <p:cNvPr id="28" name="Text 26"/>
           <p:cNvSpPr/>
           <p:nvPr/>
         </p:nvSpPr>
@@ -18645,7 +19081,7 @@
       </p:sp>
       <p:sp>
         <p:nvSpPr>
-          <p:cNvPr id="23" name="Shape 21"/>
+          <p:cNvPr id="29" name="Shape 27"/>
           <p:cNvSpPr/>
           <p:nvPr/>
         </p:nvSpPr>
@@ -18668,7 +19104,7 @@
       </p:sp>
       <p:sp>
         <p:nvSpPr>
-          <p:cNvPr id="24" name="Shape 22"/>
+          <p:cNvPr id="30" name="Shape 28"/>
           <p:cNvSpPr/>
           <p:nvPr/>
         </p:nvSpPr>
@@ -18691,7 +19127,7 @@
       </p:sp>
       <p:sp>
         <p:nvSpPr>
-          <p:cNvPr id="25" name="Shape 23"/>
+          <p:cNvPr id="31" name="Shape 29"/>
           <p:cNvSpPr/>
           <p:nvPr/>
         </p:nvSpPr>
@@ -18714,7 +19150,7 @@
       </p:sp>
       <p:sp>
         <p:nvSpPr>
-          <p:cNvPr id="26" name="Text 24"/>
+          <p:cNvPr id="32" name="Text 30"/>
           <p:cNvSpPr/>
           <p:nvPr/>
         </p:nvSpPr>
@@ -18753,7 +19189,7 @@
       </p:sp>
       <p:sp>
         <p:nvSpPr>
-          <p:cNvPr id="27" name="Text 25"/>
+          <p:cNvPr id="33" name="Text 31"/>
           <p:cNvSpPr/>
           <p:nvPr/>
         </p:nvSpPr>
@@ -18792,7 +19228,7 @@
       </p:sp>
       <p:sp>
         <p:nvSpPr>
-          <p:cNvPr id="28" name="Text 26"/>
+          <p:cNvPr id="34" name="Text 32"/>
           <p:cNvSpPr/>
           <p:nvPr/>
         </p:nvSpPr>
@@ -18831,7 +19267,7 @@
       </p:sp>
       <p:sp>
         <p:nvSpPr>
-          <p:cNvPr id="29" name="Text 27"/>
+          <p:cNvPr id="35" name="Text 33"/>
           <p:cNvSpPr/>
           <p:nvPr/>
         </p:nvSpPr>
@@ -18870,7 +19306,7 @@
       </p:sp>
       <p:sp>
         <p:nvSpPr>
-          <p:cNvPr id="30" name="Shape 28"/>
+          <p:cNvPr id="36" name="Shape 34"/>
           <p:cNvSpPr/>
           <p:nvPr/>
         </p:nvSpPr>
@@ -18893,7 +19329,7 @@
       </p:sp>
       <p:sp>
         <p:nvSpPr>
-          <p:cNvPr id="31" name="Text 29"/>
+          <p:cNvPr id="37" name="Text 35"/>
           <p:cNvSpPr/>
           <p:nvPr/>
         </p:nvSpPr>
@@ -18932,13 +19368,13 @@
       </p:sp>
       <p:sp>
         <p:nvSpPr>
-          <p:cNvPr id="32" name="Text 30"/>
-          <p:cNvSpPr/>
-          <p:nvPr/>
-        </p:nvSpPr>
-        <p:spPr>
-          <a:xfrm>
-            <a:off x="3938914" y="3234479"/>
+          <p:cNvPr id="38" name="Text 36"/>
+          <p:cNvSpPr/>
+          <p:nvPr/>
+        </p:nvSpPr>
+        <p:spPr>
+          <a:xfrm>
+            <a:off x="3938914" y="3266895"/>
             <a:ext cx="187893" cy="249448"/>
           </a:xfrm>
           <a:prstGeom prst="rect">
@@ -18971,30 +19407,30 @@
       </p:sp>
       <p:sp>
         <p:nvSpPr>
-          <p:cNvPr id="33" name="Text 31"/>
-          <p:cNvSpPr/>
-          <p:nvPr/>
-        </p:nvSpPr>
-        <p:spPr>
-          <a:xfrm>
-            <a:off x="1691640" y="3662599"/>
-            <a:ext cx="9692640" cy="532547"/>
-          </a:xfrm>
-          <a:prstGeom prst="rect">
-            <a:avLst/>
-          </a:prstGeom>
-          <a:noFill/>
-          <a:ln/>
-        </p:spPr>
-        <p:txBody>
-          <a:bodyPr wrap="square" lIns="0" tIns="0" rIns="0" bIns="0" rtlCol="0" anchor="ctr"/>
-          <a:lstStyle/>
-          <a:p>
-            <a:pPr algn="l" indent="0" marL="0">
-              <a:buNone/>
-            </a:pPr>
-            <a:r>
-              <a:rPr lang="en-US" sz="2000" dirty="0">
+          <p:cNvPr id="39" name="Text 37"/>
+          <p:cNvSpPr/>
+          <p:nvPr/>
+        </p:nvSpPr>
+        <p:spPr>
+          <a:xfrm>
+            <a:off x="1691640" y="3738372"/>
+            <a:ext cx="4805680" cy="381000"/>
+          </a:xfrm>
+          <a:prstGeom prst="rect">
+            <a:avLst/>
+          </a:prstGeom>
+          <a:noFill/>
+          <a:ln/>
+        </p:spPr>
+        <p:txBody>
+          <a:bodyPr wrap="none" lIns="0" tIns="0" rIns="0" bIns="0" rtlCol="0" anchor="ctr"/>
+          <a:lstStyle/>
+          <a:p>
+            <a:pPr algn="ctr" indent="0" marL="0">
+              <a:buNone/>
+            </a:pPr>
+            <a:r>
+              <a:rPr lang="en-US" sz="2000" b="1" dirty="0">
                 <a:solidFill>
                   <a:srgbClr val="4E5C55"/>
                 </a:solidFill>
@@ -19002,13 +19438,38 @@
                 <a:ea typeface="Microsoft JhengHei" pitchFamily="34" charset="-122"/>
                 <a:cs typeface="Microsoft JhengHei" pitchFamily="34" charset="-120"/>
               </a:rPr>
-              <a:t>根指數 3 落分母、次方 4 上分子 → 應該係 2</a:t>
-            </a:r>
-            <a:pPr algn="l" indent="0" marL="0">
-              <a:buNone/>
-            </a:pPr>
-            <a:r>
-              <a:rPr lang="en-US" sz="2000" baseline="30000" dirty="0">
+              <a:t>根指數 3 落分母、次方 4 上分子 → 應該係 </a:t>
+            </a:r>
+            <a:endParaRPr lang="en-US" sz="2000" dirty="0"/>
+          </a:p>
+        </p:txBody>
+      </p:sp>
+      <p:sp>
+        <p:nvSpPr>
+          <p:cNvPr id="40" name="Text 38"/>
+          <p:cNvSpPr/>
+          <p:nvPr/>
+        </p:nvSpPr>
+        <p:spPr>
+          <a:xfrm>
+            <a:off x="6497320" y="3738372"/>
+            <a:ext cx="238760" cy="381000"/>
+          </a:xfrm>
+          <a:prstGeom prst="rect">
+            <a:avLst/>
+          </a:prstGeom>
+          <a:noFill/>
+          <a:ln/>
+        </p:spPr>
+        <p:txBody>
+          <a:bodyPr wrap="none" lIns="0" tIns="0" rIns="0" bIns="0" rtlCol="0" anchor="ctr"/>
+          <a:lstStyle/>
+          <a:p>
+            <a:pPr algn="ctr" indent="0" marL="0">
+              <a:buNone/>
+            </a:pPr>
+            <a:r>
+              <a:rPr lang="en-US" sz="2000" b="1" dirty="0">
                 <a:solidFill>
                   <a:srgbClr val="4E5C55"/>
                 </a:solidFill>
@@ -19016,7 +19477,7 @@
                 <a:ea typeface="Microsoft JhengHei" pitchFamily="34" charset="-122"/>
                 <a:cs typeface="Microsoft JhengHei" pitchFamily="34" charset="-120"/>
               </a:rPr>
-              <a:t>4/3</a:t>
+              <a:t>2</a:t>
             </a:r>
             <a:endParaRPr lang="en-US" sz="2000" dirty="0"/>
           </a:p>
@@ -19024,7 +19485,108 @@
       </p:sp>
       <p:sp>
         <p:nvSpPr>
-          <p:cNvPr id="34" name="Shape 32"/>
+          <p:cNvPr id="41" name="Shape 39"/>
+          <p:cNvSpPr/>
+          <p:nvPr/>
+        </p:nvSpPr>
+        <p:spPr>
+          <a:xfrm>
+            <a:off x="6737263" y="3827272"/>
+            <a:ext cx="226682" cy="0"/>
+          </a:xfrm>
+          <a:prstGeom prst="line">
+            <a:avLst/>
+          </a:prstGeom>
+          <a:noFill/>
+          <a:ln w="28575">
+            <a:solidFill>
+              <a:srgbClr val="4E5C55"/>
+            </a:solidFill>
+            <a:prstDash val="solid"/>
+          </a:ln>
+        </p:spPr>
+      </p:sp>
+      <p:sp>
+        <p:nvSpPr>
+          <p:cNvPr id="42" name="Text 40"/>
+          <p:cNvSpPr/>
+          <p:nvPr/>
+        </p:nvSpPr>
+        <p:spPr>
+          <a:xfrm>
+            <a:off x="6764695" y="3629099"/>
+            <a:ext cx="171818" cy="207874"/>
+          </a:xfrm>
+          <a:prstGeom prst="rect">
+            <a:avLst/>
+          </a:prstGeom>
+          <a:noFill/>
+          <a:ln/>
+        </p:spPr>
+        <p:txBody>
+          <a:bodyPr wrap="none" lIns="0" tIns="0" rIns="0" bIns="0" rtlCol="0" anchor="ctr"/>
+          <a:lstStyle/>
+          <a:p>
+            <a:pPr algn="ctr" indent="0" marL="0">
+              <a:buNone/>
+            </a:pPr>
+            <a:r>
+              <a:rPr lang="en-US" sz="1091" b="1" dirty="0">
+                <a:solidFill>
+                  <a:srgbClr val="4E5C55"/>
+                </a:solidFill>
+                <a:latin typeface="Microsoft JhengHei" pitchFamily="34" charset="0"/>
+                <a:ea typeface="Microsoft JhengHei" pitchFamily="34" charset="-122"/>
+                <a:cs typeface="Microsoft JhengHei" pitchFamily="34" charset="-120"/>
+              </a:rPr>
+              <a:t>4</a:t>
+            </a:r>
+            <a:endParaRPr lang="en-US" sz="1091" dirty="0"/>
+          </a:p>
+        </p:txBody>
+      </p:sp>
+      <p:sp>
+        <p:nvSpPr>
+          <p:cNvPr id="43" name="Text 41"/>
+          <p:cNvSpPr/>
+          <p:nvPr/>
+        </p:nvSpPr>
+        <p:spPr>
+          <a:xfrm>
+            <a:off x="6764695" y="3852205"/>
+            <a:ext cx="171818" cy="207874"/>
+          </a:xfrm>
+          <a:prstGeom prst="rect">
+            <a:avLst/>
+          </a:prstGeom>
+          <a:noFill/>
+          <a:ln/>
+        </p:spPr>
+        <p:txBody>
+          <a:bodyPr wrap="none" lIns="0" tIns="0" rIns="0" bIns="0" rtlCol="0" anchor="ctr"/>
+          <a:lstStyle/>
+          <a:p>
+            <a:pPr algn="ctr" indent="0" marL="0">
+              <a:buNone/>
+            </a:pPr>
+            <a:r>
+              <a:rPr lang="en-US" sz="1091" b="1" dirty="0">
+                <a:solidFill>
+                  <a:srgbClr val="4E5C55"/>
+                </a:solidFill>
+                <a:latin typeface="Microsoft JhengHei" pitchFamily="34" charset="0"/>
+                <a:ea typeface="Microsoft JhengHei" pitchFamily="34" charset="-122"/>
+                <a:cs typeface="Microsoft JhengHei" pitchFamily="34" charset="-120"/>
+              </a:rPr>
+              <a:t>3</a:t>
+            </a:r>
+            <a:endParaRPr lang="en-US" sz="1091" dirty="0"/>
+          </a:p>
+        </p:txBody>
+      </p:sp>
+      <p:sp>
+        <p:nvSpPr>
+          <p:cNvPr id="44" name="Shape 42"/>
           <p:cNvSpPr/>
           <p:nvPr/>
         </p:nvSpPr>
@@ -19051,7 +19613,7 @@
       </p:sp>
       <p:sp>
         <p:nvSpPr>
-          <p:cNvPr id="35" name="Shape 33"/>
+          <p:cNvPr id="45" name="Shape 43"/>
           <p:cNvSpPr/>
           <p:nvPr/>
         </p:nvSpPr>
@@ -19071,7 +19633,7 @@
       </p:sp>
       <p:sp>
         <p:nvSpPr>
-          <p:cNvPr id="36" name="Text 34"/>
+          <p:cNvPr id="46" name="Text 44"/>
           <p:cNvSpPr/>
           <p:nvPr/>
         </p:nvSpPr>
@@ -19110,7 +19672,7 @@
       </p:sp>
       <p:sp>
         <p:nvSpPr>
-          <p:cNvPr id="37" name="Text 35"/>
+          <p:cNvPr id="47" name="Text 45"/>
           <p:cNvSpPr/>
           <p:nvPr/>
         </p:nvSpPr>
@@ -19149,7 +19711,7 @@
       </p:sp>
       <p:sp>
         <p:nvSpPr>
-          <p:cNvPr id="38" name="Text 36"/>
+          <p:cNvPr id="48" name="Text 46"/>
           <p:cNvSpPr/>
           <p:nvPr/>
         </p:nvSpPr>
@@ -19188,7 +19750,7 @@
       </p:sp>
       <p:sp>
         <p:nvSpPr>
-          <p:cNvPr id="39" name="Shape 37"/>
+          <p:cNvPr id="49" name="Shape 47"/>
           <p:cNvSpPr/>
           <p:nvPr/>
         </p:nvSpPr>
@@ -19211,7 +19773,7 @@
       </p:sp>
       <p:sp>
         <p:nvSpPr>
-          <p:cNvPr id="40" name="Text 38"/>
+          <p:cNvPr id="50" name="Text 48"/>
           <p:cNvSpPr/>
           <p:nvPr/>
         </p:nvSpPr>
@@ -19250,13 +19812,13 @@
       </p:sp>
       <p:sp>
         <p:nvSpPr>
-          <p:cNvPr id="41" name="Text 39"/>
-          <p:cNvSpPr/>
-          <p:nvPr/>
-        </p:nvSpPr>
-        <p:spPr>
-          <a:xfrm>
-            <a:off x="2687268" y="4703615"/>
+          <p:cNvPr id="51" name="Text 49"/>
+          <p:cNvSpPr/>
+          <p:nvPr/>
+        </p:nvSpPr>
+        <p:spPr>
+          <a:xfrm>
+            <a:off x="2687268" y="4736031"/>
             <a:ext cx="187893" cy="249448"/>
           </a:xfrm>
           <a:prstGeom prst="rect">
@@ -19289,7 +19851,7 @@
       </p:sp>
       <p:sp>
         <p:nvSpPr>
-          <p:cNvPr id="42" name="Text 40"/>
+          <p:cNvPr id="52" name="Text 50"/>
           <p:cNvSpPr/>
           <p:nvPr/>
         </p:nvSpPr>
@@ -19328,7 +19890,7 @@
       </p:sp>
       <p:sp>
         <p:nvSpPr>
-          <p:cNvPr id="43" name="Text 41"/>
+          <p:cNvPr id="53" name="Text 51"/>
           <p:cNvSpPr/>
           <p:nvPr/>
         </p:nvSpPr>
@@ -19367,7 +19929,7 @@
       </p:sp>
       <p:sp>
         <p:nvSpPr>
-          <p:cNvPr id="44" name="Shape 42"/>
+          <p:cNvPr id="54" name="Shape 52"/>
           <p:cNvSpPr/>
           <p:nvPr/>
         </p:nvSpPr>
@@ -19390,7 +19952,7 @@
       </p:sp>
       <p:sp>
         <p:nvSpPr>
-          <p:cNvPr id="45" name="Text 43"/>
+          <p:cNvPr id="55" name="Text 53"/>
           <p:cNvSpPr/>
           <p:nvPr/>
         </p:nvSpPr>
@@ -19429,13 +19991,13 @@
       </p:sp>
       <p:sp>
         <p:nvSpPr>
-          <p:cNvPr id="46" name="Text 44"/>
-          <p:cNvSpPr/>
-          <p:nvPr/>
-        </p:nvSpPr>
-        <p:spPr>
-          <a:xfrm>
-            <a:off x="3676306" y="4703615"/>
+          <p:cNvPr id="56" name="Text 54"/>
+          <p:cNvSpPr/>
+          <p:nvPr/>
+        </p:nvSpPr>
+        <p:spPr>
+          <a:xfrm>
+            <a:off x="3676306" y="4736031"/>
             <a:ext cx="187893" cy="249448"/>
           </a:xfrm>
           <a:prstGeom prst="rect">
@@ -19468,7 +20030,7 @@
       </p:sp>
       <p:sp>
         <p:nvSpPr>
-          <p:cNvPr id="47" name="Text 45"/>
+          <p:cNvPr id="57" name="Text 55"/>
           <p:cNvSpPr/>
           <p:nvPr/>
         </p:nvSpPr>
@@ -19507,7 +20069,7 @@
       </p:sp>
       <p:sp>
         <p:nvSpPr>
-          <p:cNvPr id="48" name="Text 46"/>
+          <p:cNvPr id="58" name="Text 56"/>
           <p:cNvSpPr/>
           <p:nvPr/>
         </p:nvSpPr>
@@ -19546,7 +20108,7 @@
       </p:sp>
       <p:sp>
         <p:nvSpPr>
-          <p:cNvPr id="49" name="Shape 47"/>
+          <p:cNvPr id="59" name="Shape 57"/>
           <p:cNvSpPr/>
           <p:nvPr/>
         </p:nvSpPr>
@@ -19569,7 +20131,7 @@
       </p:sp>
       <p:sp>
         <p:nvSpPr>
-          <p:cNvPr id="50" name="Text 48"/>
+          <p:cNvPr id="60" name="Text 58"/>
           <p:cNvSpPr/>
           <p:nvPr/>
         </p:nvSpPr>
@@ -19608,13 +20170,13 @@
       </p:sp>
       <p:sp>
         <p:nvSpPr>
-          <p:cNvPr id="51" name="Text 49"/>
-          <p:cNvSpPr/>
-          <p:nvPr/>
-        </p:nvSpPr>
-        <p:spPr>
-          <a:xfrm>
-            <a:off x="4665344" y="4703615"/>
+          <p:cNvPr id="61" name="Text 59"/>
+          <p:cNvSpPr/>
+          <p:nvPr/>
+        </p:nvSpPr>
+        <p:spPr>
+          <a:xfrm>
+            <a:off x="4665344" y="4736031"/>
             <a:ext cx="187893" cy="249448"/>
           </a:xfrm>
           <a:prstGeom prst="rect">
@@ -19647,30 +20209,30 @@
       </p:sp>
       <p:sp>
         <p:nvSpPr>
-          <p:cNvPr id="52" name="Text 50"/>
-          <p:cNvSpPr/>
-          <p:nvPr/>
-        </p:nvSpPr>
-        <p:spPr>
-          <a:xfrm>
-            <a:off x="1691640" y="5131735"/>
-            <a:ext cx="9692640" cy="532547"/>
-          </a:xfrm>
-          <a:prstGeom prst="rect">
-            <a:avLst/>
-          </a:prstGeom>
-          <a:noFill/>
-          <a:ln/>
-        </p:spPr>
-        <p:txBody>
-          <a:bodyPr wrap="square" lIns="0" tIns="0" rIns="0" bIns="0" rtlCol="0" anchor="ctr"/>
-          <a:lstStyle/>
-          <a:p>
-            <a:pPr algn="l" indent="0" marL="0">
-              <a:buNone/>
-            </a:pPr>
-            <a:r>
-              <a:rPr lang="en-US" sz="2000" dirty="0">
+          <p:cNvPr id="62" name="Text 60"/>
+          <p:cNvSpPr/>
+          <p:nvPr/>
+        </p:nvSpPr>
+        <p:spPr>
+          <a:xfrm>
+            <a:off x="1691640" y="5207508"/>
+            <a:ext cx="2631440" cy="381000"/>
+          </a:xfrm>
+          <a:prstGeom prst="rect">
+            <a:avLst/>
+          </a:prstGeom>
+          <a:noFill/>
+          <a:ln/>
+        </p:spPr>
+        <p:txBody>
+          <a:bodyPr wrap="none" lIns="0" tIns="0" rIns="0" bIns="0" rtlCol="0" anchor="ctr"/>
+          <a:lstStyle/>
+          <a:p>
+            <a:pPr algn="ctr" indent="0" marL="0">
+              <a:buNone/>
+            </a:pPr>
+            <a:r>
+              <a:rPr lang="en-US" sz="2000" b="1" dirty="0">
                 <a:solidFill>
                   <a:srgbClr val="4E5C55"/>
                 </a:solidFill>
@@ -19678,7 +20240,7 @@
                 <a:ea typeface="Microsoft JhengHei" pitchFamily="34" charset="-122"/>
                 <a:cs typeface="Microsoft JhengHei" pitchFamily="34" charset="-120"/>
               </a:rPr>
-              <a:t>底數一樣，指數相減：2/3 − 1/3 = 1/3</a:t>
+              <a:t>底數一樣，指數相減：</a:t>
             </a:r>
             <a:endParaRPr lang="en-US" sz="2000" dirty="0"/>
           </a:p>
@@ -19686,7 +20248,388 @@
       </p:sp>
       <p:sp>
         <p:nvSpPr>
-          <p:cNvPr id="53" name="Shape 51"/>
+          <p:cNvPr id="63" name="Shape 61"/>
+          <p:cNvSpPr/>
+          <p:nvPr/>
+        </p:nvSpPr>
+        <p:spPr>
+          <a:xfrm>
+            <a:off x="4368800" y="5398008"/>
+            <a:ext cx="275946" cy="0"/>
+          </a:xfrm>
+          <a:prstGeom prst="line">
+            <a:avLst/>
+          </a:prstGeom>
+          <a:noFill/>
+          <a:ln w="28575">
+            <a:solidFill>
+              <a:srgbClr val="4E5C55"/>
+            </a:solidFill>
+            <a:prstDash val="solid"/>
+          </a:ln>
+        </p:spPr>
+      </p:sp>
+      <p:sp>
+        <p:nvSpPr>
+          <p:cNvPr id="64" name="Text 62"/>
+          <p:cNvSpPr/>
+          <p:nvPr/>
+        </p:nvSpPr>
+        <p:spPr>
+          <a:xfrm>
+            <a:off x="4396232" y="5078374"/>
+            <a:ext cx="221082" cy="335280"/>
+          </a:xfrm>
+          <a:prstGeom prst="rect">
+            <a:avLst/>
+          </a:prstGeom>
+          <a:noFill/>
+          <a:ln/>
+        </p:spPr>
+        <p:txBody>
+          <a:bodyPr wrap="none" lIns="0" tIns="0" rIns="0" bIns="0" rtlCol="0" anchor="ctr"/>
+          <a:lstStyle/>
+          <a:p>
+            <a:pPr algn="ctr" indent="0" marL="0">
+              <a:buNone/>
+            </a:pPr>
+            <a:r>
+              <a:rPr lang="en-US" sz="1760" b="1" dirty="0">
+                <a:solidFill>
+                  <a:srgbClr val="4E5C55"/>
+                </a:solidFill>
+                <a:latin typeface="Microsoft JhengHei" pitchFamily="34" charset="0"/>
+                <a:ea typeface="Microsoft JhengHei" pitchFamily="34" charset="-122"/>
+                <a:cs typeface="Microsoft JhengHei" pitchFamily="34" charset="-120"/>
+              </a:rPr>
+              <a:t>2</a:t>
+            </a:r>
+            <a:endParaRPr lang="en-US" sz="1760" dirty="0"/>
+          </a:p>
+        </p:txBody>
+      </p:sp>
+      <p:sp>
+        <p:nvSpPr>
+          <p:cNvPr id="65" name="Text 63"/>
+          <p:cNvSpPr/>
+          <p:nvPr/>
+        </p:nvSpPr>
+        <p:spPr>
+          <a:xfrm>
+            <a:off x="4396232" y="5410200"/>
+            <a:ext cx="221082" cy="335280"/>
+          </a:xfrm>
+          <a:prstGeom prst="rect">
+            <a:avLst/>
+          </a:prstGeom>
+          <a:noFill/>
+          <a:ln/>
+        </p:spPr>
+        <p:txBody>
+          <a:bodyPr wrap="none" lIns="0" tIns="0" rIns="0" bIns="0" rtlCol="0" anchor="ctr"/>
+          <a:lstStyle/>
+          <a:p>
+            <a:pPr algn="ctr" indent="0" marL="0">
+              <a:buNone/>
+            </a:pPr>
+            <a:r>
+              <a:rPr lang="en-US" sz="1760" b="1" dirty="0">
+                <a:solidFill>
+                  <a:srgbClr val="4E5C55"/>
+                </a:solidFill>
+                <a:latin typeface="Microsoft JhengHei" pitchFamily="34" charset="0"/>
+                <a:ea typeface="Microsoft JhengHei" pitchFamily="34" charset="-122"/>
+                <a:cs typeface="Microsoft JhengHei" pitchFamily="34" charset="-120"/>
+              </a:rPr>
+              <a:t>3</a:t>
+            </a:r>
+            <a:endParaRPr lang="en-US" sz="1760" dirty="0"/>
+          </a:p>
+        </p:txBody>
+      </p:sp>
+      <p:sp>
+        <p:nvSpPr>
+          <p:cNvPr id="66" name="Text 64"/>
+          <p:cNvSpPr/>
+          <p:nvPr/>
+        </p:nvSpPr>
+        <p:spPr>
+          <a:xfrm>
+            <a:off x="4690466" y="5207508"/>
+            <a:ext cx="370840" cy="381000"/>
+          </a:xfrm>
+          <a:prstGeom prst="rect">
+            <a:avLst/>
+          </a:prstGeom>
+          <a:noFill/>
+          <a:ln/>
+        </p:spPr>
+        <p:txBody>
+          <a:bodyPr wrap="none" lIns="0" tIns="0" rIns="0" bIns="0" rtlCol="0" anchor="ctr"/>
+          <a:lstStyle/>
+          <a:p>
+            <a:pPr algn="ctr" indent="0" marL="0">
+              <a:buNone/>
+            </a:pPr>
+            <a:r>
+              <a:rPr lang="en-US" sz="2000" b="1" dirty="0">
+                <a:solidFill>
+                  <a:srgbClr val="4E5C55"/>
+                </a:solidFill>
+                <a:latin typeface="Microsoft JhengHei" pitchFamily="34" charset="0"/>
+                <a:ea typeface="Microsoft JhengHei" pitchFamily="34" charset="-122"/>
+                <a:cs typeface="Microsoft JhengHei" pitchFamily="34" charset="-120"/>
+              </a:rPr>
+              <a:t> − </a:t>
+            </a:r>
+            <a:endParaRPr lang="en-US" sz="2000" dirty="0"/>
+          </a:p>
+        </p:txBody>
+      </p:sp>
+      <p:sp>
+        <p:nvSpPr>
+          <p:cNvPr id="67" name="Shape 65"/>
+          <p:cNvSpPr/>
+          <p:nvPr/>
+        </p:nvSpPr>
+        <p:spPr>
+          <a:xfrm>
+            <a:off x="5107026" y="5398008"/>
+            <a:ext cx="275946" cy="0"/>
+          </a:xfrm>
+          <a:prstGeom prst="line">
+            <a:avLst/>
+          </a:prstGeom>
+          <a:noFill/>
+          <a:ln w="28575">
+            <a:solidFill>
+              <a:srgbClr val="4E5C55"/>
+            </a:solidFill>
+            <a:prstDash val="solid"/>
+          </a:ln>
+        </p:spPr>
+      </p:sp>
+      <p:sp>
+        <p:nvSpPr>
+          <p:cNvPr id="68" name="Text 66"/>
+          <p:cNvSpPr/>
+          <p:nvPr/>
+        </p:nvSpPr>
+        <p:spPr>
+          <a:xfrm>
+            <a:off x="5134458" y="5078374"/>
+            <a:ext cx="221082" cy="335280"/>
+          </a:xfrm>
+          <a:prstGeom prst="rect">
+            <a:avLst/>
+          </a:prstGeom>
+          <a:noFill/>
+          <a:ln/>
+        </p:spPr>
+        <p:txBody>
+          <a:bodyPr wrap="none" lIns="0" tIns="0" rIns="0" bIns="0" rtlCol="0" anchor="ctr"/>
+          <a:lstStyle/>
+          <a:p>
+            <a:pPr algn="ctr" indent="0" marL="0">
+              <a:buNone/>
+            </a:pPr>
+            <a:r>
+              <a:rPr lang="en-US" sz="1760" b="1" dirty="0">
+                <a:solidFill>
+                  <a:srgbClr val="4E5C55"/>
+                </a:solidFill>
+                <a:latin typeface="Microsoft JhengHei" pitchFamily="34" charset="0"/>
+                <a:ea typeface="Microsoft JhengHei" pitchFamily="34" charset="-122"/>
+                <a:cs typeface="Microsoft JhengHei" pitchFamily="34" charset="-120"/>
+              </a:rPr>
+              <a:t>1</a:t>
+            </a:r>
+            <a:endParaRPr lang="en-US" sz="1760" dirty="0"/>
+          </a:p>
+        </p:txBody>
+      </p:sp>
+      <p:sp>
+        <p:nvSpPr>
+          <p:cNvPr id="69" name="Text 67"/>
+          <p:cNvSpPr/>
+          <p:nvPr/>
+        </p:nvSpPr>
+        <p:spPr>
+          <a:xfrm>
+            <a:off x="5134458" y="5410200"/>
+            <a:ext cx="221082" cy="335280"/>
+          </a:xfrm>
+          <a:prstGeom prst="rect">
+            <a:avLst/>
+          </a:prstGeom>
+          <a:noFill/>
+          <a:ln/>
+        </p:spPr>
+        <p:txBody>
+          <a:bodyPr wrap="none" lIns="0" tIns="0" rIns="0" bIns="0" rtlCol="0" anchor="ctr"/>
+          <a:lstStyle/>
+          <a:p>
+            <a:pPr algn="ctr" indent="0" marL="0">
+              <a:buNone/>
+            </a:pPr>
+            <a:r>
+              <a:rPr lang="en-US" sz="1760" b="1" dirty="0">
+                <a:solidFill>
+                  <a:srgbClr val="4E5C55"/>
+                </a:solidFill>
+                <a:latin typeface="Microsoft JhengHei" pitchFamily="34" charset="0"/>
+                <a:ea typeface="Microsoft JhengHei" pitchFamily="34" charset="-122"/>
+                <a:cs typeface="Microsoft JhengHei" pitchFamily="34" charset="-120"/>
+              </a:rPr>
+              <a:t>3</a:t>
+            </a:r>
+            <a:endParaRPr lang="en-US" sz="1760" dirty="0"/>
+          </a:p>
+        </p:txBody>
+      </p:sp>
+      <p:sp>
+        <p:nvSpPr>
+          <p:cNvPr id="70" name="Text 68"/>
+          <p:cNvSpPr/>
+          <p:nvPr/>
+        </p:nvSpPr>
+        <p:spPr>
+          <a:xfrm>
+            <a:off x="5428691" y="5207508"/>
+            <a:ext cx="370840" cy="381000"/>
+          </a:xfrm>
+          <a:prstGeom prst="rect">
+            <a:avLst/>
+          </a:prstGeom>
+          <a:noFill/>
+          <a:ln/>
+        </p:spPr>
+        <p:txBody>
+          <a:bodyPr wrap="none" lIns="0" tIns="0" rIns="0" bIns="0" rtlCol="0" anchor="ctr"/>
+          <a:lstStyle/>
+          <a:p>
+            <a:pPr algn="ctr" indent="0" marL="0">
+              <a:buNone/>
+            </a:pPr>
+            <a:r>
+              <a:rPr lang="en-US" sz="2000" b="1" dirty="0">
+                <a:solidFill>
+                  <a:srgbClr val="4E5C55"/>
+                </a:solidFill>
+                <a:latin typeface="Microsoft JhengHei" pitchFamily="34" charset="0"/>
+                <a:ea typeface="Microsoft JhengHei" pitchFamily="34" charset="-122"/>
+                <a:cs typeface="Microsoft JhengHei" pitchFamily="34" charset="-120"/>
+              </a:rPr>
+              <a:t> = </a:t>
+            </a:r>
+            <a:endParaRPr lang="en-US" sz="2000" dirty="0"/>
+          </a:p>
+        </p:txBody>
+      </p:sp>
+      <p:sp>
+        <p:nvSpPr>
+          <p:cNvPr id="71" name="Shape 69"/>
+          <p:cNvSpPr/>
+          <p:nvPr/>
+        </p:nvSpPr>
+        <p:spPr>
+          <a:xfrm>
+            <a:off x="5845251" y="5398008"/>
+            <a:ext cx="275946" cy="0"/>
+          </a:xfrm>
+          <a:prstGeom prst="line">
+            <a:avLst/>
+          </a:prstGeom>
+          <a:noFill/>
+          <a:ln w="28575">
+            <a:solidFill>
+              <a:srgbClr val="4E5C55"/>
+            </a:solidFill>
+            <a:prstDash val="solid"/>
+          </a:ln>
+        </p:spPr>
+      </p:sp>
+      <p:sp>
+        <p:nvSpPr>
+          <p:cNvPr id="72" name="Text 70"/>
+          <p:cNvSpPr/>
+          <p:nvPr/>
+        </p:nvSpPr>
+        <p:spPr>
+          <a:xfrm>
+            <a:off x="5872683" y="5078374"/>
+            <a:ext cx="221082" cy="335280"/>
+          </a:xfrm>
+          <a:prstGeom prst="rect">
+            <a:avLst/>
+          </a:prstGeom>
+          <a:noFill/>
+          <a:ln/>
+        </p:spPr>
+        <p:txBody>
+          <a:bodyPr wrap="none" lIns="0" tIns="0" rIns="0" bIns="0" rtlCol="0" anchor="ctr"/>
+          <a:lstStyle/>
+          <a:p>
+            <a:pPr algn="ctr" indent="0" marL="0">
+              <a:buNone/>
+            </a:pPr>
+            <a:r>
+              <a:rPr lang="en-US" sz="1760" b="1" dirty="0">
+                <a:solidFill>
+                  <a:srgbClr val="4E5C55"/>
+                </a:solidFill>
+                <a:latin typeface="Microsoft JhengHei" pitchFamily="34" charset="0"/>
+                <a:ea typeface="Microsoft JhengHei" pitchFamily="34" charset="-122"/>
+                <a:cs typeface="Microsoft JhengHei" pitchFamily="34" charset="-120"/>
+              </a:rPr>
+              <a:t>1</a:t>
+            </a:r>
+            <a:endParaRPr lang="en-US" sz="1760" dirty="0"/>
+          </a:p>
+        </p:txBody>
+      </p:sp>
+      <p:sp>
+        <p:nvSpPr>
+          <p:cNvPr id="73" name="Text 71"/>
+          <p:cNvSpPr/>
+          <p:nvPr/>
+        </p:nvSpPr>
+        <p:spPr>
+          <a:xfrm>
+            <a:off x="5872683" y="5410200"/>
+            <a:ext cx="221082" cy="335280"/>
+          </a:xfrm>
+          <a:prstGeom prst="rect">
+            <a:avLst/>
+          </a:prstGeom>
+          <a:noFill/>
+          <a:ln/>
+        </p:spPr>
+        <p:txBody>
+          <a:bodyPr wrap="none" lIns="0" tIns="0" rIns="0" bIns="0" rtlCol="0" anchor="ctr"/>
+          <a:lstStyle/>
+          <a:p>
+            <a:pPr algn="ctr" indent="0" marL="0">
+              <a:buNone/>
+            </a:pPr>
+            <a:r>
+              <a:rPr lang="en-US" sz="1760" b="1" dirty="0">
+                <a:solidFill>
+                  <a:srgbClr val="4E5C55"/>
+                </a:solidFill>
+                <a:latin typeface="Microsoft JhengHei" pitchFamily="34" charset="0"/>
+                <a:ea typeface="Microsoft JhengHei" pitchFamily="34" charset="-122"/>
+                <a:cs typeface="Microsoft JhengHei" pitchFamily="34" charset="-120"/>
+              </a:rPr>
+              <a:t>3</a:t>
+            </a:r>
+            <a:endParaRPr lang="en-US" sz="1760" dirty="0"/>
+          </a:p>
+        </p:txBody>
+      </p:sp>
+      <p:sp>
+        <p:nvSpPr>
+          <p:cNvPr id="74" name="Shape 72"/>
           <p:cNvSpPr/>
           <p:nvPr/>
         </p:nvSpPr>
@@ -19713,7 +20656,7 @@
       </p:sp>
       <p:sp>
         <p:nvSpPr>
-          <p:cNvPr id="54" name="Text 52"/>
+          <p:cNvPr id="75" name="Text 73"/>
           <p:cNvSpPr/>
           <p:nvPr/>
         </p:nvSpPr>

</xml_diff>